<commit_message>
Iterations 4-5: v4 UX redesign, core fixes (77 tests), prompt v5, deck and docs updates (work in progress)
Co-Authored-By: Claude Opus 5.5 <noreply@anthropic.com>
</commit_message>
<xml_diff>
--- a/presentation/ShiftSwap-Team7.pptx
+++ b/presentation/ShiftSwap-Team7.pptx
@@ -596,7 +596,7 @@
           </a:p>
           <a:p>
             <a:r>
-              <a:t>We did not write code by hand. We wrote one prompt that treats the specification as a contract, and let the AI coding assistant build the system. Every ambiguity the build found went into a prompt log and back into the specification. Three versions were needed. Finally we re-ran the last prompt in an empty folder to check that it reproduces the system. I hand over to Minkyung.</a:t>
+              <a:t>We did not write code by hand. We wrote one prompt that treats the specification as a contract, and let the AI coding assistant build the system. Every ambiguity the build found went into a prompt log and back into the specification. Five versions were needed. The last one came from re-running the prompt in an empty folder: the rebuilt system worked, but its function signatures differed from ours, so version five supplies our test files as the contract. I hand over to Minkyung.</a:t>
             </a:r>
           </a:p>
         </p:txBody>
@@ -671,7 +671,7 @@
           </a:p>
           <a:p>
             <a:r>
-              <a:t>Here is the system with our demo café. Seoyeon requested a substitute for Wednesday. The system found two eligible co-workers and notified both at once. Minho accepts directly from his inbox. When Doyun tries a moment later, he is told the shift is already taken by Minho.</a:t>
+              <a:t>Here is the system with our demo café. Seoyeon requested a substitute for Wednesday. The system found two eligible co-workers and notified both at once. Minho does not have to look for it: his Home screen shows the request first, together with what accepting means for him — sixteen to twenty-one hours this week, holiday allowance unchanged. One tap accepts. When Doyun tries a moment later, he is told Minho was faster.</a:t>
             </a:r>
           </a:p>
         </p:txBody>
@@ -746,7 +746,7 @@
           </a:p>
           <a:p>
             <a:r>
-              <a:t>Before approving, the owner sees the effect on both workers. Minho's scheduled hours rise from sixteen to twenty-one, but his contract hours stay sixteen, so he keeps the holiday allowance of three point two hours, which is 33,024 won. After approval the board shows the handover in amber.</a:t>
+              <a:t>The owner opens the app and sees one thing to handle today. The card states the effect on both workers. Minho's scheduled hours rise from sixteen to twenty-one, but his contract hours stay sixteen, so he keeps the holiday allowance of three point two hours, which is 33,024 won. After approval the board shows the handover in amber.</a:t>
             </a:r>
           </a:p>
         </p:txBody>
@@ -896,7 +896,7 @@
           </a:p>
           <a:p>
             <a:r>
-              <a:t>All 58 automated tests pass. They include boundary values such as fourteen point nine nine versus fifteen hours, the forty-hour cap, both attendance policies, and the concurrent acceptance. The traceability matrix in the report links every functional requirement to its use case, screen, function and tests.</a:t>
+              <a:t>All 77 automated tests pass. They include boundary values such as fourteen point nine nine versus fifteen hours, the forty-hour cap, both attendance policies, and the concurrent acceptance. The traceability matrix in the report links every functional requirement to its use case, screen, function and tests.</a:t>
             </a:r>
           </a:p>
         </p:txBody>
@@ -1196,7 +1196,7 @@
           </a:p>
           <a:p>
             <a:r>
-              <a:t>From interviews and the legal sources we wrote twenty-one functional requirements and twelve non-functional requirements, classified as product, organisational and external requirements as in Chapter 8. The core logic is captured in twelve business rules, and the data in twelve tables. This is well above the course minimum of five use cases and four tables.</a:t>
+              <a:t>From interviews and the legal sources we wrote twenty-one functional requirements and thirteen non-functional requirements, classified as product, organisational and external requirements as in Chapter 8. The core logic is captured in twelve business rules, and the data in twelve tables. This is well above the course minimum of five use cases and four tables.</a:t>
             </a:r>
           </a:p>
         </p:txBody>
@@ -4894,7 +4894,7 @@
                 </a:solidFill>
                 <a:latin typeface="Arial"/>
               </a:rPr>
-              <a:t>Vibe coding: three prompt versions</a:t>
+              <a:t>Vibe coding: five prompt versions</a:t>
             </a:r>
           </a:p>
         </p:txBody>
@@ -4948,7 +4948,7 @@
         </p:nvGraphicFramePr>
         <p:xfrm>
           <a:off x="640000" y="1450000"/>
-          <a:ext cx="10912000" cy="2800000"/>
+          <a:ext cx="10912000" cy="3500000"/>
         </p:xfrm>
         <a:graphic>
           <a:graphicData uri="http://schemas.openxmlformats.org/drawingml/2006/table">
@@ -5086,7 +5086,7 @@
                           </a:solidFill>
                           <a:latin typeface="Arial"/>
                         </a:rPr>
-                        <a:t>Acknowledgement column, notification recipients, S7 walkthrough; tests 52 → 58</a:t>
+                        <a:t>Acknowledgement column, notification recipients, S7 walkthrough</a:t>
                       </a:r>
                     </a:p>
                   </a:txBody>
@@ -5178,7 +5178,7 @@
                           </a:solidFill>
                           <a:latin typeface="Courier New"/>
                         </a:rPr>
-                        <a:t>Check</a:t>
+                        <a:t>v4</a:t>
                       </a:r>
                     </a:p>
                   </a:txBody>
@@ -5200,7 +5200,7 @@
                           </a:solidFill>
                           <a:latin typeface="Arial"/>
                         </a:rPr>
-                        <a:t>Final prompt re-run in an empty folder</a:t>
+                        <a:t>UX redesign review: task-first, one primary action</a:t>
                       </a:r>
                     </a:p>
                   </a:txBody>
@@ -5222,7 +5222,75 @@
                           </a:solidFill>
                           <a:latin typeface="Arial"/>
                         </a:rPr>
-                        <a:t>Rebuilt system run against our test suite</a:t>
+                        <a:t>Role Home screens, 3-step request flow, consequences shown before commit</a:t>
+                      </a:r>
+                    </a:p>
+                  </a:txBody>
+                  <a:tcPr>
+                    <a:solidFill>
+                      <a:srgbClr val="FFFFFF"/>
+                    </a:solidFill>
+                  </a:tcPr>
+                </a:tc>
+              </a:tr>
+              <a:tr h="700000">
+                <a:tc>
+                  <a:txBody>
+                    <a:bodyPr/>
+                    <a:lstStyle/>
+                    <a:p>
+                      <a:r>
+                        <a:rPr sz="1400" b="1">
+                          <a:solidFill>
+                            <a:srgbClr val="1C2230"/>
+                          </a:solidFill>
+                          <a:latin typeface="Courier New"/>
+                        </a:rPr>
+                        <a:t>v5</a:t>
+                      </a:r>
+                    </a:p>
+                  </a:txBody>
+                  <a:tcPr>
+                    <a:solidFill>
+                      <a:srgbClr val="F4F6F9"/>
+                    </a:solidFill>
+                  </a:tcPr>
+                </a:tc>
+                <a:tc>
+                  <a:txBody>
+                    <a:bodyPr/>
+                    <a:lstStyle/>
+                    <a:p>
+                      <a:r>
+                        <a:rPr sz="1500" b="0">
+                          <a:solidFill>
+                            <a:srgbClr val="1C2230"/>
+                          </a:solidFill>
+                          <a:latin typeface="Arial"/>
+                        </a:rPr>
+                        <a:t>Rebuild in an empty folder + independent code review</a:t>
+                      </a:r>
+                    </a:p>
+                  </a:txBody>
+                  <a:tcPr>
+                    <a:solidFill>
+                      <a:srgbClr val="FFFFFF"/>
+                    </a:solidFill>
+                  </a:tcPr>
+                </a:tc>
+                <a:tc>
+                  <a:txBody>
+                    <a:bodyPr/>
+                    <a:lstStyle/>
+                    <a:p>
+                      <a:r>
+                        <a:rPr sz="1500" b="0">
+                          <a:solidFill>
+                            <a:srgbClr val="1C2230"/>
+                          </a:solidFill>
+                          <a:latin typeface="Arial"/>
+                        </a:rPr>
+                        <a:t>Tests become input; 7 defects fixed; tests 77/77</a:t>
                       </a:r>
                     </a:p>
                   </a:txBody>
@@ -5333,7 +5401,7 @@
                 </a:solidFill>
                 <a:latin typeface="Arial"/>
               </a:rPr>
-              <a:t>Demo: request and accept</a:t>
+              <a:t>Demo: the request comes to you</a:t>
             </a:r>
           </a:p>
         </p:txBody>
@@ -5393,8 +5461,8 @@
         </p:blipFill>
         <p:spPr>
           <a:xfrm>
-            <a:off x="640000" y="1786728"/>
-            <a:ext cx="10912000" cy="3376543"/>
+            <a:off x="5424367" y="1250000"/>
+            <a:ext cx="1343266" cy="4450000"/>
           </a:xfrm>
           <a:prstGeom prst="rect">
             <a:avLst/>
@@ -5435,7 +5503,7 @@
                 </a:solidFill>
                 <a:latin typeface="Arial"/>
               </a:rPr>
-              <a:t>Minho's inbox: Accept or Decline directly on the notification (at most 2 clicks, NFR-01)</a:t>
+              <a:t>Minho's Home: the request card shows the effect on his week before he taps Accept (one tap, NFR-01)</a:t>
             </a:r>
           </a:p>
         </p:txBody>
@@ -5536,7 +5604,7 @@
                 </a:solidFill>
                 <a:latin typeface="Arial"/>
               </a:rPr>
-              <a:t>Approval shows the effect on pay</a:t>
+              <a:t>The owner decides on one card</a:t>
             </a:r>
           </a:p>
         </p:txBody>
@@ -5596,8 +5664,8 @@
         </p:blipFill>
         <p:spPr>
           <a:xfrm>
-            <a:off x="3187862" y="1250000"/>
-            <a:ext cx="5816276" cy="4450000"/>
+            <a:off x="2931556" y="1250000"/>
+            <a:ext cx="6328888" cy="4450000"/>
           </a:xfrm>
           <a:prstGeom prst="rect">
             <a:avLst/>
@@ -5638,7 +5706,7 @@
                 </a:solidFill>
                 <a:latin typeface="Arial"/>
               </a:rPr>
-              <a:t>Before/after comparison for both workers: Minho 16 → 21 scheduled hours, eligibility unchanged</a:t>
+              <a:t>Owner Home: '1 thing to handle today' — the swap, its effect on both workers, and one Approve button</a:t>
             </a:r>
           </a:p>
         </p:txBody>
@@ -5799,8 +5867,8 @@
         </p:blipFill>
         <p:spPr>
           <a:xfrm>
-            <a:off x="3608131" y="1250000"/>
-            <a:ext cx="4975738" cy="4450000"/>
+            <a:off x="3192840" y="1250000"/>
+            <a:ext cx="5806320" cy="4450000"/>
           </a:xfrm>
           <a:prstGeom prst="rect">
             <a:avLst/>
@@ -5841,7 +5909,7 @@
                 </a:solidFill>
                 <a:latin typeface="Arial"/>
               </a:rPr>
-              <a:t>Doyun's wage is below the 2026 minimum: the owner must acknowledge before confirming</a:t>
+              <a:t>Doyun's wage is below the 2026 minimum: 'Confirm September pay' stays disabled, with the reason, until acknowledged</a:t>
             </a:r>
           </a:p>
         </p:txBody>
@@ -5995,7 +6063,7 @@
         <p:spPr>
           <a:xfrm>
             <a:off x="640000" y="1450000"/>
-            <a:ext cx="2528000" cy="900000"/>
+            <a:ext cx="3437333" cy="900000"/>
           </a:xfrm>
           <a:prstGeom prst="rect">
             <a:avLst/>
@@ -6020,7 +6088,7 @@
                 </a:solidFill>
                 <a:latin typeface="Arial"/>
               </a:rPr>
-              <a:t>58/58</a:t>
+              <a:t>77/77</a:t>
             </a:r>
           </a:p>
         </p:txBody>
@@ -6034,7 +6102,7 @@
         <p:spPr>
           <a:xfrm>
             <a:off x="640000" y="2350000"/>
-            <a:ext cx="2528000" cy="400000"/>
+            <a:ext cx="3437333" cy="400000"/>
           </a:xfrm>
           <a:prstGeom prst="rect">
             <a:avLst/>
@@ -6073,7 +6141,7 @@
         <p:spPr>
           <a:xfrm>
             <a:off x="640000" y="2750000"/>
-            <a:ext cx="2528000" cy="500000"/>
+            <a:ext cx="3437333" cy="500000"/>
           </a:xfrm>
           <a:prstGeom prst="rect">
             <a:avLst/>
@@ -6111,8 +6179,8 @@
         </p:nvSpPr>
         <p:spPr>
           <a:xfrm>
-            <a:off x="3368000" y="1450000"/>
-            <a:ext cx="2528000" cy="900000"/>
+            <a:off x="4277333" y="1450000"/>
+            <a:ext cx="3437333" cy="900000"/>
           </a:xfrm>
           <a:prstGeom prst="rect">
             <a:avLst/>
@@ -6150,8 +6218,8 @@
         </p:nvSpPr>
         <p:spPr>
           <a:xfrm>
-            <a:off x="3368000" y="2350000"/>
-            <a:ext cx="2528000" cy="400000"/>
+            <a:off x="4277333" y="2350000"/>
+            <a:ext cx="3437333" cy="400000"/>
           </a:xfrm>
           <a:prstGeom prst="rect">
             <a:avLst/>
@@ -6189,8 +6257,8 @@
         </p:nvSpPr>
         <p:spPr>
           <a:xfrm>
-            <a:off x="3368000" y="2750000"/>
-            <a:ext cx="2528000" cy="500000"/>
+            <a:off x="4277333" y="2750000"/>
+            <a:ext cx="3437333" cy="500000"/>
           </a:xfrm>
           <a:prstGeom prst="rect">
             <a:avLst/>
@@ -6228,8 +6296,125 @@
         </p:nvSpPr>
         <p:spPr>
           <a:xfrm>
-            <a:off x="6096000" y="1450000"/>
-            <a:ext cx="2528000" cy="900000"/>
+            <a:off x="7914666" y="1450000"/>
+            <a:ext cx="3437333" cy="900000"/>
+          </a:xfrm>
+          <a:prstGeom prst="rect">
+            <a:avLst/>
+          </a:prstGeom>
+          <a:noFill/>
+        </p:spPr>
+        <p:txBody>
+          <a:bodyPr wrap="square">
+            <a:spAutoFit/>
+          </a:bodyPr>
+          <a:lstStyle/>
+          <a:p>
+            <a:pPr algn="l">
+              <a:spcAft>
+                <a:spcPts val="2400"/>
+              </a:spcAft>
+            </a:pPr>
+            <a:r>
+              <a:rPr sz="4800" b="1">
+                <a:solidFill>
+                  <a:srgbClr val="2B5BD7"/>
+                </a:solidFill>
+                <a:latin typeface="Arial"/>
+              </a:rPr>
+              <a:t>77/77</a:t>
+            </a:r>
+          </a:p>
+        </p:txBody>
+      </p:sp>
+      <p:sp>
+        <p:nvSpPr>
+          <p:cNvPr id="12" name="TextBox 11"/>
+          <p:cNvSpPr txBox="1"/>
+          <p:nvPr/>
+        </p:nvSpPr>
+        <p:spPr>
+          <a:xfrm>
+            <a:off x="7914666" y="2350000"/>
+            <a:ext cx="3437333" cy="400000"/>
+          </a:xfrm>
+          <a:prstGeom prst="rect">
+            <a:avLst/>
+          </a:prstGeom>
+          <a:noFill/>
+        </p:spPr>
+        <p:txBody>
+          <a:bodyPr wrap="square">
+            <a:spAutoFit/>
+          </a:bodyPr>
+          <a:lstStyle/>
+          <a:p>
+            <a:pPr algn="l">
+              <a:spcAft>
+                <a:spcPts val="900"/>
+              </a:spcAft>
+            </a:pPr>
+            <a:r>
+              <a:rPr sz="1800" b="1">
+                <a:solidFill>
+                  <a:srgbClr val="1C2230"/>
+                </a:solidFill>
+                <a:latin typeface="Arial"/>
+              </a:rPr>
+              <a:t>tests pass in a clean rebuild</a:t>
+            </a:r>
+          </a:p>
+        </p:txBody>
+      </p:sp>
+      <p:sp>
+        <p:nvSpPr>
+          <p:cNvPr id="13" name="TextBox 12"/>
+          <p:cNvSpPr txBox="1"/>
+          <p:nvPr/>
+        </p:nvSpPr>
+        <p:spPr>
+          <a:xfrm>
+            <a:off x="7914666" y="2750000"/>
+            <a:ext cx="3437333" cy="500000"/>
+          </a:xfrm>
+          <a:prstGeom prst="rect">
+            <a:avLst/>
+          </a:prstGeom>
+          <a:noFill/>
+        </p:spPr>
+        <p:txBody>
+          <a:bodyPr wrap="square">
+            <a:spAutoFit/>
+          </a:bodyPr>
+          <a:lstStyle/>
+          <a:p>
+            <a:pPr algn="l">
+              <a:spcAft>
+                <a:spcPts val="650"/>
+              </a:spcAft>
+            </a:pPr>
+            <a:r>
+              <a:rPr sz="1300" b="0">
+                <a:solidFill>
+                  <a:srgbClr val="4A5163"/>
+                </a:solidFill>
+                <a:latin typeface="Arial"/>
+              </a:rPr>
+              <a:t>prompt v5 re-run in an empty folder</a:t>
+            </a:r>
+          </a:p>
+        </p:txBody>
+      </p:sp>
+      <p:sp>
+        <p:nvSpPr>
+          <p:cNvPr id="14" name="TextBox 13"/>
+          <p:cNvSpPr txBox="1"/>
+          <p:nvPr/>
+        </p:nvSpPr>
+        <p:spPr>
+          <a:xfrm>
+            <a:off x="640000" y="3450000"/>
+            <a:ext cx="3437333" cy="900000"/>
           </a:xfrm>
           <a:prstGeom prst="rect">
             <a:avLst/>
@@ -6261,14 +6446,14 @@
       </p:sp>
       <p:sp>
         <p:nvSpPr>
-          <p:cNvPr id="12" name="TextBox 11"/>
+          <p:cNvPr id="15" name="TextBox 14"/>
           <p:cNvSpPr txBox="1"/>
           <p:nvPr/>
         </p:nvSpPr>
         <p:spPr>
           <a:xfrm>
-            <a:off x="6096000" y="2350000"/>
-            <a:ext cx="2528000" cy="400000"/>
+            <a:off x="640000" y="4350000"/>
+            <a:ext cx="3437333" cy="400000"/>
           </a:xfrm>
           <a:prstGeom prst="rect">
             <a:avLst/>
@@ -6300,14 +6485,14 @@
       </p:sp>
       <p:sp>
         <p:nvSpPr>
-          <p:cNvPr id="13" name="TextBox 12"/>
+          <p:cNvPr id="16" name="TextBox 15"/>
           <p:cNvSpPr txBox="1"/>
           <p:nvPr/>
         </p:nvSpPr>
         <p:spPr>
           <a:xfrm>
-            <a:off x="6096000" y="2750000"/>
-            <a:ext cx="2528000" cy="500000"/>
+            <a:off x="640000" y="4750000"/>
+            <a:ext cx="3437333" cy="500000"/>
           </a:xfrm>
           <a:prstGeom prst="rect">
             <a:avLst/>
@@ -6339,14 +6524,14 @@
       </p:sp>
       <p:sp>
         <p:nvSpPr>
-          <p:cNvPr id="14" name="TextBox 13"/>
+          <p:cNvPr id="17" name="TextBox 16"/>
           <p:cNvSpPr txBox="1"/>
           <p:nvPr/>
         </p:nvSpPr>
         <p:spPr>
           <a:xfrm>
-            <a:off x="8824000" y="1450000"/>
-            <a:ext cx="2528000" cy="900000"/>
+            <a:off x="4277333" y="3450000"/>
+            <a:ext cx="3437333" cy="900000"/>
           </a:xfrm>
           <a:prstGeom prst="rect">
             <a:avLst/>
@@ -6378,14 +6563,14 @@
       </p:sp>
       <p:sp>
         <p:nvSpPr>
-          <p:cNvPr id="15" name="TextBox 14"/>
+          <p:cNvPr id="18" name="TextBox 17"/>
           <p:cNvSpPr txBox="1"/>
           <p:nvPr/>
         </p:nvSpPr>
         <p:spPr>
           <a:xfrm>
-            <a:off x="8824000" y="2350000"/>
-            <a:ext cx="2528000" cy="400000"/>
+            <a:off x="4277333" y="4350000"/>
+            <a:ext cx="3437333" cy="400000"/>
           </a:xfrm>
           <a:prstGeom prst="rect">
             <a:avLst/>
@@ -6417,14 +6602,14 @@
       </p:sp>
       <p:sp>
         <p:nvSpPr>
-          <p:cNvPr id="16" name="TextBox 15"/>
+          <p:cNvPr id="19" name="TextBox 18"/>
           <p:cNvSpPr txBox="1"/>
           <p:nvPr/>
         </p:nvSpPr>
         <p:spPr>
           <a:xfrm>
-            <a:off x="8824000" y="2750000"/>
-            <a:ext cx="2528000" cy="500000"/>
+            <a:off x="4277333" y="4750000"/>
+            <a:ext cx="3437333" cy="500000"/>
           </a:xfrm>
           <a:prstGeom prst="rect">
             <a:avLst/>
@@ -6697,7 +6882,7 @@
                           </a:solidFill>
                           <a:latin typeface="Arial"/>
                         </a:rPr>
-                        <a:t>13 use cases · 12 tables · 3,644 lines of application code · 650 lines of tests</a:t>
+                        <a:t>13 use cases · 12 tables · 5,380 lines of application code · 902 lines of tests</a:t>
                       </a:r>
                     </a:p>
                   </a:txBody>
@@ -8163,7 +8348,7 @@
                 </a:solidFill>
                 <a:latin typeface="Arial"/>
               </a:rPr>
-              <a:t>12</a:t>
+              <a:t>13</a:t>
             </a:r>
           </a:p>
         </p:txBody>
@@ -9278,8 +9463,8 @@
         </p:blipFill>
         <p:spPr>
           <a:xfrm>
-            <a:off x="1037618" y="1250000"/>
-            <a:ext cx="10116763" cy="4450000"/>
+            <a:off x="1104296" y="1250000"/>
+            <a:ext cx="9983408" cy="4450000"/>
           </a:xfrm>
           <a:prstGeom prst="rect">
             <a:avLst/>
@@ -9481,8 +9666,8 @@
         </p:blipFill>
         <p:spPr>
           <a:xfrm>
-            <a:off x="3410453" y="1250000"/>
-            <a:ext cx="5371094" cy="4450000"/>
+            <a:off x="3862531" y="1250000"/>
+            <a:ext cx="4466938" cy="4450000"/>
           </a:xfrm>
           <a:prstGeom prst="rect">
             <a:avLst/>

</xml_diff>

<commit_message>
Iteration 6: availability removed, can't answer and FAILED ending; Korean display names; 84 tests, check 128/128; docs, UML and deck updated
Co-Authored-By: Claude Opus 5.5 <noreply@anthropic.com>
</commit_message>
<xml_diff>
--- a/presentation/ShiftSwap-Team7.pptx
+++ b/presentation/ShiftSwap-Team7.pptx
@@ -20,6 +20,7 @@
     <p:sldId id="268" r:id="rId20"/>
     <p:sldId id="269" r:id="rId21"/>
     <p:sldId id="270" r:id="rId22"/>
+    <p:sldId id="271" r:id="rId23"/>
   </p:sldIdLst>
   <p:sldSz cx="12192000" cy="6858000" type="screen4x3"/>
   <p:notesSz cx="6858000" cy="9144000"/>
@@ -591,12 +592,12 @@
           <a:lstStyle/>
           <a:p>
             <a:r>
-              <a:t>[Hyoungdo Kim · about 1.4 min]</a:t>
-            </a:r>
-          </a:p>
-          <a:p>
-            <a:r>
-              <a:t>We did not write code by hand. We wrote one prompt that treats the specification as a contract, and let the AI coding assistant build the system. Every ambiguity the build found went into a prompt log and back into the specification. Five versions were needed. The last one came from re-running the prompt in an empty folder: the rebuilt system worked, but its function signatures differed from ours, so version five supplies our test files as the contract. I hand over to Minkyung.</a:t>
+              <a:t>[Hyoungdo Kim · about 0.9 min]</a:t>
+            </a:r>
+          </a:p>
+          <a:p>
+            <a:r>
+              <a:t>This state diagram is the contract between screens, services and tests: every transition has a triggering function and at least one test. For example, a request that reaches its deadline or its shift start without approval expires automatically.</a:t>
             </a:r>
           </a:p>
         </p:txBody>
@@ -666,12 +667,12 @@
           <a:lstStyle/>
           <a:p>
             <a:r>
-              <a:t>[Minkyung Kim · about 1.2 min]</a:t>
-            </a:r>
-          </a:p>
-          <a:p>
-            <a:r>
-              <a:t>Here is the system with our demo café. Seoyeon requested a substitute for Wednesday. The system found two eligible co-workers and notified both at once. Minho does not have to look for it: his Home screen shows the request first, together with what accepting means for him — sixteen to twenty-one hours this week, holiday allowance unchanged. One tap accepts. When Doyun tries a moment later, he is told Minho was faster.</a:t>
+              <a:t>[Hyoungdo Kim · about 1.4 min]</a:t>
+            </a:r>
+          </a:p>
+          <a:p>
+            <a:r>
+              <a:t>We did not write code by hand. We wrote one prompt that treats the specification as a contract, and let the AI coding assistant build the system. Every ambiguity the build found went into a prompt log and back into the specification. Six versions were needed. The last one came from re-running the prompt in an empty folder: the rebuilt system worked, but its function signatures differed from ours, so version five supplies our test files as the contract. I hand over to Minkyung.</a:t>
             </a:r>
           </a:p>
         </p:txBody>
@@ -746,7 +747,7 @@
           </a:p>
           <a:p>
             <a:r>
-              <a:t>The owner opens the app and sees one thing to handle today. The card states the effect on both workers. Minho's scheduled hours rise from sixteen to twenty-one, but his contract hours stay sixteen, so he keeps the holiday allowance of three point two hours, which is 33,024 won. After approval the board shows the handover in amber.</a:t>
+              <a:t>Here is the system with our demo café. Seoyeon requested a substitute for Wednesday. The system asked the three co-workers who are free at that time, all at once. Minho does not have to look for it: his Home screen shows the request first, together with what accepting means for him — sixteen to twenty-one hours this week, holiday allowance unchanged. One tap accepts. When Doyun tries a moment later, he is told Minho was faster.</a:t>
             </a:r>
           </a:p>
         </p:txBody>
@@ -816,12 +817,12 @@
           <a:lstStyle/>
           <a:p>
             <a:r>
-              <a:t>[Minkyung Kim · about 0.9 min]</a:t>
-            </a:r>
-          </a:p>
-          <a:p>
-            <a:r>
-              <a:t>At month end the owner generates payroll. Doyun's hourly wage is below the 2026 minimum wage, so the row is flagged and the month cannot be confirmed until the owner acknowledges the warning.</a:t>
+              <a:t>[Minkyung Kim · about 1.2 min]</a:t>
+            </a:r>
+          </a:p>
+          <a:p>
+            <a:r>
+              <a:t>The owner opens the app and sees one thing to handle today. The card states the effect on both workers. Minho's scheduled hours rise from sixteen to twenty-one, but his contract hours stay sixteen, so he keeps the holiday allowance of three point two hours, which is 33,024 won. After approval the board shows the handover in amber.</a:t>
             </a:r>
           </a:p>
         </p:txBody>
@@ -891,12 +892,12 @@
           <a:lstStyle/>
           <a:p>
             <a:r>
-              <a:t>[Minkyung Kim · about 1.0 min]</a:t>
-            </a:r>
-          </a:p>
-          <a:p>
-            <a:r>
-              <a:t>All 77 automated tests pass. They include boundary values such as fourteen point nine nine versus fifteen hours, the forty-hour cap, both attendance policies, and the concurrent acceptance. The traceability matrix in the report links every functional requirement to its use case, screen, function and tests.</a:t>
+              <a:t>[Minkyung Kim · about 0.9 min]</a:t>
+            </a:r>
+          </a:p>
+          <a:p>
+            <a:r>
+              <a:t>At month end the owner generates payroll. Doyun's hourly wage is below the 2026 minimum wage, so the row is flagged and the month cannot be confirmed until the owner acknowledges the warning.</a:t>
             </a:r>
           </a:p>
         </p:txBody>
@@ -971,6 +972,81 @@
           </a:p>
           <a:p>
             <a:r>
+              <a:t>All 84 automated tests pass. They include boundary values such as fourteen point nine nine versus fifteen hours, the forty-hour cap, both attendance policies, and the concurrent acceptance. The traceability matrix in the report links every functional requirement to its use case, screen, function and tests.</a:t>
+            </a:r>
+          </a:p>
+        </p:txBody>
+      </p:sp>
+      <p:sp>
+        <p:nvSpPr>
+          <p:cNvPr id="4" name="Slide Number Placeholder 3"/>
+          <p:cNvSpPr>
+            <a:spLocks noGrp="1"/>
+          </p:cNvSpPr>
+          <p:nvPr>
+            <p:ph type="sldNum" idx="5" sz="quarter"/>
+          </p:nvPr>
+        </p:nvSpPr>
+        <p:spPr/>
+      </p:sp>
+    </p:spTree>
+  </p:cSld>
+  <p:clrMapOvr>
+    <a:masterClrMapping/>
+  </p:clrMapOvr>
+</p:notes>
+</file>
+
+<file path=ppt/notesSlides/notesSlide16.xml><?xml version="1.0" encoding="utf-8"?>
+<p:notes xmlns:a="http://schemas.openxmlformats.org/drawingml/2006/main" xmlns:p="http://schemas.openxmlformats.org/presentationml/2006/main" xmlns:r="http://schemas.openxmlformats.org/officeDocument/2006/relationships">
+  <p:cSld>
+    <p:spTree>
+      <p:nvGrpSpPr>
+        <p:cNvPr id="1" name=""/>
+        <p:cNvGrpSpPr/>
+        <p:nvPr/>
+      </p:nvGrpSpPr>
+      <p:grpSpPr>
+        <a:xfrm>
+          <a:off x="0" y="0"/>
+          <a:ext cx="0" cy="0"/>
+          <a:chOff x="0" y="0"/>
+          <a:chExt cx="0" cy="0"/>
+        </a:xfrm>
+      </p:grpSpPr>
+      <p:sp>
+        <p:nvSpPr>
+          <p:cNvPr id="2" name="Slide Image Placeholder 1"/>
+          <p:cNvSpPr>
+            <a:spLocks noGrp="1"/>
+          </p:cNvSpPr>
+          <p:nvPr>
+            <p:ph type="sldImg" idx="2"/>
+          </p:nvPr>
+        </p:nvSpPr>
+        <p:spPr/>
+      </p:sp>
+      <p:sp>
+        <p:nvSpPr>
+          <p:cNvPr id="3" name="Notes Placeholder 2"/>
+          <p:cNvSpPr>
+            <a:spLocks noGrp="1"/>
+          </p:cNvSpPr>
+          <p:nvPr>
+            <p:ph type="body" idx="3" sz="quarter"/>
+          </p:nvPr>
+        </p:nvSpPr>
+        <p:spPr/>
+        <p:txBody>
+          <a:bodyPr/>
+          <a:lstStyle/>
+          <a:p>
+            <a:r>
+              <a:t>[Minkyung Kim · about 1.0 min]</a:t>
+            </a:r>
+          </a:p>
+          <a:p>
+            <a:r>
               <a:t>To sum up: the owner no longer contacts workers one by one, candidates answer in two clicks, and every swap updates both workers' hours and pay eligibility. The limits are those of a client-only demo: no real login and data kept in one browser. The next step would be a server and a field test in the café. Thank you. We are happy to take questions.</a:t>
             </a:r>
           </a:p>
@@ -1266,7 +1342,7 @@
           <a:lstStyle/>
           <a:p>
             <a:r>
-              <a:t>[Hyewon Kim · about 1.2 min]</a:t>
+              <a:t>[Hyewon Kim · about 1.0 min]</a:t>
             </a:r>
           </a:p>
           <a:p>
@@ -1341,12 +1417,12 @@
           <a:lstStyle/>
           <a:p>
             <a:r>
-              <a:t>[Hyewon Kim · about 1.2 min]</a:t>
-            </a:r>
-          </a:p>
-          <a:p>
-            <a:r>
-              <a:t>The legal rules became business rules that can be tested. For example, the holiday allowance exists only when the contract has at least fifteen hours a week and the worker was not absent; the hours are capped at forty. Because handing a shift over is legally unclear, the attendance effect of a swap is a setting the owner chooses. I now hand over to Hyoungdo.</a:t>
+              <a:t>[Hyewon Kim · about 1.0 min]</a:t>
+            </a:r>
+          </a:p>
+          <a:p>
+            <a:r>
+              <a:t>The legal rules became business rules that can be tested. For example, the holiday allowance exists only when the contract has at least fifteen hours a week and the worker was not absent; the hours are capped at forty. Because handing a shift over is legally unclear, the attendance effect of a swap is a setting the owner chooses.</a:t>
             </a:r>
           </a:p>
         </p:txBody>
@@ -1416,12 +1492,12 @@
           <a:lstStyle/>
           <a:p>
             <a:r>
-              <a:t>[Hyoungdo Kim · about 0.9 min]</a:t>
-            </a:r>
-          </a:p>
-          <a:p>
-            <a:r>
-              <a:t>The system runs entirely in the browser, so it can be hosted on GitHub Pages without a server. The user interface calls application services, one per use-case step. The services call pure rule functions that contain no database code, which is why every rule can be unit-tested. The data lives in a real SQLite database compiled to WebAssembly and is saved in the browser.</a:t>
+              <a:t>[Hyewon Kim · about 0.8 min]</a:t>
+            </a:r>
+          </a:p>
+          <a:p>
+            <a:r>
+              <a:t>Using the running system showed us a dead end: when nobody's registered availability matched, the owner was told there was no candidate but had nothing to do, and workers had to keep their availability up to date. We changed the requirement. Availability is gone; every co-worker who is not already working is asked, and anyone can answer 'can't'. If all of them do, the request ends clearly: the requester is asked to call the owner, and the owner gets one card to acknowledge. We retired UC-02 and FR-03 instead of reusing their numbers, so traceability stays intact. I now hand over to Hyoungdo.</a:t>
             </a:r>
           </a:p>
         </p:txBody>
@@ -1491,12 +1567,12 @@
           <a:lstStyle/>
           <a:p>
             <a:r>
-              <a:t>[Hyoungdo Kim · about 1.0 min]</a:t>
-            </a:r>
-          </a:p>
-          <a:p>
-            <a:r>
-              <a:t>The most delicate interaction is two candidates accepting at almost the same time. Each acceptance runs in one transaction that first re-reads the request state. Only the first finds it REQUESTED; the second sees ACCEPTED, rolls back, and the worker is told who already took the shift.</a:t>
+              <a:t>[Hyoungdo Kim · about 0.9 min]</a:t>
+            </a:r>
+          </a:p>
+          <a:p>
+            <a:r>
+              <a:t>The system runs entirely in the browser, so it can be hosted on GitHub Pages without a server. The user interface calls application services, one per use-case step. The services call pure rule functions that contain no database code, which is why every rule can be unit-tested. The data lives in a real SQLite database compiled to WebAssembly and is saved in the browser.</a:t>
             </a:r>
           </a:p>
         </p:txBody>
@@ -1566,12 +1642,12 @@
           <a:lstStyle/>
           <a:p>
             <a:r>
-              <a:t>[Hyoungdo Kim · about 0.9 min]</a:t>
-            </a:r>
-          </a:p>
-          <a:p>
-            <a:r>
-              <a:t>This state diagram is the contract between screens, services and tests: every transition has a triggering function and at least one test. For example, a request that reaches its deadline or its shift start without approval expires automatically.</a:t>
+              <a:t>[Hyoungdo Kim · about 1.0 min]</a:t>
+            </a:r>
+          </a:p>
+          <a:p>
+            <a:r>
+              <a:t>The most delicate interaction is two candidates accepting at almost the same time. Each acceptance runs in one transaction that first re-reads the request state. Only the first finds it REQUESTED; the second sees ACCEPTED, rolls back, and the worker is told who already took the shift.</a:t>
             </a:r>
           </a:p>
         </p:txBody>
@@ -4894,7 +4970,7 @@
                 </a:solidFill>
                 <a:latin typeface="Arial"/>
               </a:rPr>
-              <a:t>Vibe coding: five prompt versions</a:t>
+              <a:t>Life of a substitute request</a:t>
             </a:r>
           </a:p>
         </p:txBody>
@@ -4933,7 +5009,210 @@
                 </a:solidFill>
                 <a:latin typeface="Arial"/>
               </a:rPr>
-              <a:t>10 / 15   ·   Hyoungdo Kim</a:t>
+              <a:t>10 / 16   ·   Hyoungdo Kim</a:t>
+            </a:r>
+          </a:p>
+        </p:txBody>
+      </p:sp>
+      <p:pic>
+        <p:nvPicPr>
+          <p:cNvPr id="5" name="Picture 4" descr="state-subrequest.png"/>
+          <p:cNvPicPr>
+            <a:picLocks noChangeAspect="1"/>
+          </p:cNvPicPr>
+          <p:nvPr/>
+        </p:nvPicPr>
+        <p:blipFill>
+          <a:blip r:embed="rId2"/>
+          <a:stretch>
+            <a:fillRect/>
+          </a:stretch>
+        </p:blipFill>
+        <p:spPr>
+          <a:xfrm>
+            <a:off x="640000" y="1912100"/>
+            <a:ext cx="10912000" cy="3125800"/>
+          </a:xfrm>
+          <a:prstGeom prst="rect">
+            <a:avLst/>
+          </a:prstGeom>
+        </p:spPr>
+      </p:pic>
+      <p:sp>
+        <p:nvSpPr>
+          <p:cNvPr id="6" name="TextBox 5"/>
+          <p:cNvSpPr txBox="1"/>
+          <p:nvPr/>
+        </p:nvSpPr>
+        <p:spPr>
+          <a:xfrm>
+            <a:off x="640000" y="5750000"/>
+            <a:ext cx="10912000" cy="400000"/>
+          </a:xfrm>
+          <a:prstGeom prst="rect">
+            <a:avLst/>
+          </a:prstGeom>
+          <a:noFill/>
+        </p:spPr>
+        <p:txBody>
+          <a:bodyPr wrap="square">
+            <a:spAutoFit/>
+          </a:bodyPr>
+          <a:lstStyle/>
+          <a:p>
+            <a:pPr algn="l">
+              <a:spcAft>
+                <a:spcPts val="650"/>
+              </a:spcAft>
+            </a:pPr>
+            <a:r>
+              <a:rPr sz="1300" b="0">
+                <a:solidFill>
+                  <a:srgbClr val="4A5163"/>
+                </a:solidFill>
+                <a:latin typeface="Arial"/>
+              </a:rPr>
+              <a:t>State diagram: REQUESTED → ACCEPTED → APPROVED / REJECTED, with EXPIRED and CANCELLED</a:t>
+            </a:r>
+          </a:p>
+        </p:txBody>
+      </p:sp>
+    </p:spTree>
+  </p:cSld>
+  <p:clrMapOvr>
+    <a:masterClrMapping/>
+  </p:clrMapOvr>
+</p:sld>
+</file>
+
+<file path=ppt/slides/slide11.xml><?xml version="1.0" encoding="utf-8"?>
+<p:sld xmlns:a="http://schemas.openxmlformats.org/drawingml/2006/main" xmlns:p="http://schemas.openxmlformats.org/presentationml/2006/main" xmlns:r="http://schemas.openxmlformats.org/officeDocument/2006/relationships">
+  <p:cSld>
+    <p:spTree>
+      <p:nvGrpSpPr>
+        <p:cNvPr id="1" name=""/>
+        <p:cNvGrpSpPr/>
+        <p:nvPr/>
+      </p:nvGrpSpPr>
+      <p:grpSpPr/>
+      <p:sp>
+        <p:nvSpPr>
+          <p:cNvPr id="2" name="Rectangle 1"/>
+          <p:cNvSpPr/>
+          <p:nvPr/>
+        </p:nvSpPr>
+        <p:spPr>
+          <a:xfrm>
+            <a:off x="0" y="0"/>
+            <a:ext cx="120000" cy="6858000"/>
+          </a:xfrm>
+          <a:prstGeom prst="rect">
+            <a:avLst/>
+          </a:prstGeom>
+          <a:solidFill>
+            <a:srgbClr val="E9A23B"/>
+          </a:solidFill>
+          <a:ln>
+            <a:noFill/>
+          </a:ln>
+          <a:effectLst/>
+        </p:spPr>
+        <p:style>
+          <a:lnRef idx="1">
+            <a:schemeClr val="accent1"/>
+          </a:lnRef>
+          <a:fillRef idx="3">
+            <a:schemeClr val="accent1"/>
+          </a:fillRef>
+          <a:effectRef idx="2">
+            <a:schemeClr val="accent1"/>
+          </a:effectRef>
+          <a:fontRef idx="minor">
+            <a:schemeClr val="lt1"/>
+          </a:fontRef>
+        </p:style>
+        <p:txBody>
+          <a:bodyPr rtlCol="0" anchor="ctr"/>
+          <a:lstStyle/>
+          <a:p>
+            <a:pPr algn="ctr"/>
+          </a:p>
+        </p:txBody>
+      </p:sp>
+      <p:sp>
+        <p:nvSpPr>
+          <p:cNvPr id="3" name="TextBox 2"/>
+          <p:cNvSpPr txBox="1"/>
+          <p:nvPr/>
+        </p:nvSpPr>
+        <p:spPr>
+          <a:xfrm>
+            <a:off x="640000" y="430000"/>
+            <a:ext cx="10912000" cy="700000"/>
+          </a:xfrm>
+          <a:prstGeom prst="rect">
+            <a:avLst/>
+          </a:prstGeom>
+          <a:noFill/>
+        </p:spPr>
+        <p:txBody>
+          <a:bodyPr wrap="square">
+            <a:spAutoFit/>
+          </a:bodyPr>
+          <a:lstStyle/>
+          <a:p>
+            <a:pPr algn="l">
+              <a:spcAft>
+                <a:spcPts val="1500"/>
+              </a:spcAft>
+            </a:pPr>
+            <a:r>
+              <a:rPr sz="3000" b="1">
+                <a:solidFill>
+                  <a:srgbClr val="1C2230"/>
+                </a:solidFill>
+                <a:latin typeface="Arial"/>
+              </a:rPr>
+              <a:t>Vibe coding: six prompt versions</a:t>
+            </a:r>
+          </a:p>
+        </p:txBody>
+      </p:sp>
+      <p:sp>
+        <p:nvSpPr>
+          <p:cNvPr id="4" name="TextBox 3"/>
+          <p:cNvSpPr txBox="1"/>
+          <p:nvPr/>
+        </p:nvSpPr>
+        <p:spPr>
+          <a:xfrm>
+            <a:off x="640000" y="6338000"/>
+            <a:ext cx="10912000" cy="300000"/>
+          </a:xfrm>
+          <a:prstGeom prst="rect">
+            <a:avLst/>
+          </a:prstGeom>
+          <a:noFill/>
+        </p:spPr>
+        <p:txBody>
+          <a:bodyPr wrap="square">
+            <a:spAutoFit/>
+          </a:bodyPr>
+          <a:lstStyle/>
+          <a:p>
+            <a:pPr algn="l">
+              <a:spcAft>
+                <a:spcPts val="550"/>
+              </a:spcAft>
+            </a:pPr>
+            <a:r>
+              <a:rPr sz="1100" b="0">
+                <a:solidFill>
+                  <a:srgbClr val="4A5163"/>
+                </a:solidFill>
+                <a:latin typeface="Arial"/>
+              </a:rPr>
+              <a:t>11 / 16   ·   Hyoungdo Kim</a:t>
             </a:r>
           </a:p>
         </p:txBody>
@@ -4948,7 +5227,7 @@
         </p:nvGraphicFramePr>
         <p:xfrm>
           <a:off x="640000" y="1450000"/>
-          <a:ext cx="10912000" cy="3500000"/>
+          <a:ext cx="10912000" cy="4200000"/>
         </p:xfrm>
         <a:graphic>
           <a:graphicData uri="http://schemas.openxmlformats.org/drawingml/2006/table">
@@ -5290,7 +5569,75 @@
                           </a:solidFill>
                           <a:latin typeface="Arial"/>
                         </a:rPr>
-                        <a:t>Tests become input; 7 defects fixed; tests 77/77</a:t>
+                        <a:t>Tests become input; 7 defects fixed</a:t>
+                      </a:r>
+                    </a:p>
+                  </a:txBody>
+                  <a:tcPr>
+                    <a:solidFill>
+                      <a:srgbClr val="FFFFFF"/>
+                    </a:solidFill>
+                  </a:tcPr>
+                </a:tc>
+              </a:tr>
+              <a:tr h="700000">
+                <a:tc>
+                  <a:txBody>
+                    <a:bodyPr/>
+                    <a:lstStyle/>
+                    <a:p>
+                      <a:r>
+                        <a:rPr sz="1400" b="1">
+                          <a:solidFill>
+                            <a:srgbClr val="1C2230"/>
+                          </a:solidFill>
+                          <a:latin typeface="Courier New"/>
+                        </a:rPr>
+                        <a:t>v6</a:t>
+                      </a:r>
+                    </a:p>
+                  </a:txBody>
+                  <a:tcPr>
+                    <a:solidFill>
+                      <a:srgbClr val="F4F6F9"/>
+                    </a:solidFill>
+                  </a:tcPr>
+                </a:tc>
+                <a:tc>
+                  <a:txBody>
+                    <a:bodyPr/>
+                    <a:lstStyle/>
+                    <a:p>
+                      <a:r>
+                        <a:rPr sz="1500" b="0">
+                          <a:solidFill>
+                            <a:srgbClr val="1C2230"/>
+                          </a:solidFill>
+                          <a:latin typeface="Arial"/>
+                        </a:rPr>
+                        <a:t>Requirements change after using the app</a:t>
+                      </a:r>
+                    </a:p>
+                  </a:txBody>
+                  <a:tcPr>
+                    <a:solidFill>
+                      <a:srgbClr val="FFFFFF"/>
+                    </a:solidFill>
+                  </a:tcPr>
+                </a:tc>
+                <a:tc>
+                  <a:txBody>
+                    <a:bodyPr/>
+                    <a:lstStyle/>
+                    <a:p>
+                      <a:r>
+                        <a:rPr sz="1500" b="0">
+                          <a:solidFill>
+                            <a:srgbClr val="1C2230"/>
+                          </a:solidFill>
+                          <a:latin typeface="Arial"/>
+                        </a:rPr>
+                        <a:t>Availability removed; 'can't' answer; FAILED ending</a:t>
                       </a:r>
                     </a:p>
                   </a:txBody>
@@ -5313,7 +5660,7 @@
 </p:sld>
 </file>
 
-<file path=ppt/slides/slide11.xml><?xml version="1.0" encoding="utf-8"?>
+<file path=ppt/slides/slide12.xml><?xml version="1.0" encoding="utf-8"?>
 <p:sld xmlns:a="http://schemas.openxmlformats.org/drawingml/2006/main" xmlns:p="http://schemas.openxmlformats.org/presentationml/2006/main" xmlns:r="http://schemas.openxmlformats.org/officeDocument/2006/relationships">
   <p:cSld>
     <p:spTree>
@@ -5440,7 +5787,7 @@
                 </a:solidFill>
                 <a:latin typeface="Arial"/>
               </a:rPr>
-              <a:t>11 / 15   ·   Minkyung Kim</a:t>
+              <a:t>12 / 16   ·   Minkyung Kim</a:t>
             </a:r>
           </a:p>
         </p:txBody>
@@ -5504,209 +5851,6 @@
                 <a:latin typeface="Arial"/>
               </a:rPr>
               <a:t>Minho's Home: the request card shows the effect on his week before he taps Accept (one tap, NFR-01)</a:t>
-            </a:r>
-          </a:p>
-        </p:txBody>
-      </p:sp>
-    </p:spTree>
-  </p:cSld>
-  <p:clrMapOvr>
-    <a:masterClrMapping/>
-  </p:clrMapOvr>
-</p:sld>
-</file>
-
-<file path=ppt/slides/slide12.xml><?xml version="1.0" encoding="utf-8"?>
-<p:sld xmlns:a="http://schemas.openxmlformats.org/drawingml/2006/main" xmlns:p="http://schemas.openxmlformats.org/presentationml/2006/main" xmlns:r="http://schemas.openxmlformats.org/officeDocument/2006/relationships">
-  <p:cSld>
-    <p:spTree>
-      <p:nvGrpSpPr>
-        <p:cNvPr id="1" name=""/>
-        <p:cNvGrpSpPr/>
-        <p:nvPr/>
-      </p:nvGrpSpPr>
-      <p:grpSpPr/>
-      <p:sp>
-        <p:nvSpPr>
-          <p:cNvPr id="2" name="Rectangle 1"/>
-          <p:cNvSpPr/>
-          <p:nvPr/>
-        </p:nvSpPr>
-        <p:spPr>
-          <a:xfrm>
-            <a:off x="0" y="0"/>
-            <a:ext cx="120000" cy="6858000"/>
-          </a:xfrm>
-          <a:prstGeom prst="rect">
-            <a:avLst/>
-          </a:prstGeom>
-          <a:solidFill>
-            <a:srgbClr val="1C2230"/>
-          </a:solidFill>
-          <a:ln>
-            <a:noFill/>
-          </a:ln>
-          <a:effectLst/>
-        </p:spPr>
-        <p:style>
-          <a:lnRef idx="1">
-            <a:schemeClr val="accent1"/>
-          </a:lnRef>
-          <a:fillRef idx="3">
-            <a:schemeClr val="accent1"/>
-          </a:fillRef>
-          <a:effectRef idx="2">
-            <a:schemeClr val="accent1"/>
-          </a:effectRef>
-          <a:fontRef idx="minor">
-            <a:schemeClr val="lt1"/>
-          </a:fontRef>
-        </p:style>
-        <p:txBody>
-          <a:bodyPr rtlCol="0" anchor="ctr"/>
-          <a:lstStyle/>
-          <a:p>
-            <a:pPr algn="ctr"/>
-          </a:p>
-        </p:txBody>
-      </p:sp>
-      <p:sp>
-        <p:nvSpPr>
-          <p:cNvPr id="3" name="TextBox 2"/>
-          <p:cNvSpPr txBox="1"/>
-          <p:nvPr/>
-        </p:nvSpPr>
-        <p:spPr>
-          <a:xfrm>
-            <a:off x="640000" y="430000"/>
-            <a:ext cx="10912000" cy="700000"/>
-          </a:xfrm>
-          <a:prstGeom prst="rect">
-            <a:avLst/>
-          </a:prstGeom>
-          <a:noFill/>
-        </p:spPr>
-        <p:txBody>
-          <a:bodyPr wrap="square">
-            <a:spAutoFit/>
-          </a:bodyPr>
-          <a:lstStyle/>
-          <a:p>
-            <a:pPr algn="l">
-              <a:spcAft>
-                <a:spcPts val="1500"/>
-              </a:spcAft>
-            </a:pPr>
-            <a:r>
-              <a:rPr sz="3000" b="1">
-                <a:solidFill>
-                  <a:srgbClr val="1C2230"/>
-                </a:solidFill>
-                <a:latin typeface="Arial"/>
-              </a:rPr>
-              <a:t>The owner decides on one card</a:t>
-            </a:r>
-          </a:p>
-        </p:txBody>
-      </p:sp>
-      <p:sp>
-        <p:nvSpPr>
-          <p:cNvPr id="4" name="TextBox 3"/>
-          <p:cNvSpPr txBox="1"/>
-          <p:nvPr/>
-        </p:nvSpPr>
-        <p:spPr>
-          <a:xfrm>
-            <a:off x="640000" y="6338000"/>
-            <a:ext cx="10912000" cy="300000"/>
-          </a:xfrm>
-          <a:prstGeom prst="rect">
-            <a:avLst/>
-          </a:prstGeom>
-          <a:noFill/>
-        </p:spPr>
-        <p:txBody>
-          <a:bodyPr wrap="square">
-            <a:spAutoFit/>
-          </a:bodyPr>
-          <a:lstStyle/>
-          <a:p>
-            <a:pPr algn="l">
-              <a:spcAft>
-                <a:spcPts val="550"/>
-              </a:spcAft>
-            </a:pPr>
-            <a:r>
-              <a:rPr sz="1100" b="0">
-                <a:solidFill>
-                  <a:srgbClr val="4A5163"/>
-                </a:solidFill>
-                <a:latin typeface="Arial"/>
-              </a:rPr>
-              <a:t>12 / 15   ·   Minkyung Kim</a:t>
-            </a:r>
-          </a:p>
-        </p:txBody>
-      </p:sp>
-      <p:pic>
-        <p:nvPicPr>
-          <p:cNvPr id="5" name="Picture 4" descr="ui-06-approval.png"/>
-          <p:cNvPicPr>
-            <a:picLocks noChangeAspect="1"/>
-          </p:cNvPicPr>
-          <p:nvPr/>
-        </p:nvPicPr>
-        <p:blipFill>
-          <a:blip r:embed="rId2"/>
-          <a:stretch>
-            <a:fillRect/>
-          </a:stretch>
-        </p:blipFill>
-        <p:spPr>
-          <a:xfrm>
-            <a:off x="2931556" y="1250000"/>
-            <a:ext cx="6328888" cy="4450000"/>
-          </a:xfrm>
-          <a:prstGeom prst="rect">
-            <a:avLst/>
-          </a:prstGeom>
-        </p:spPr>
-      </p:pic>
-      <p:sp>
-        <p:nvSpPr>
-          <p:cNvPr id="6" name="TextBox 5"/>
-          <p:cNvSpPr txBox="1"/>
-          <p:nvPr/>
-        </p:nvSpPr>
-        <p:spPr>
-          <a:xfrm>
-            <a:off x="640000" y="5750000"/>
-            <a:ext cx="10912000" cy="400000"/>
-          </a:xfrm>
-          <a:prstGeom prst="rect">
-            <a:avLst/>
-          </a:prstGeom>
-          <a:noFill/>
-        </p:spPr>
-        <p:txBody>
-          <a:bodyPr wrap="square">
-            <a:spAutoFit/>
-          </a:bodyPr>
-          <a:lstStyle/>
-          <a:p>
-            <a:pPr algn="l">
-              <a:spcAft>
-                <a:spcPts val="650"/>
-              </a:spcAft>
-            </a:pPr>
-            <a:r>
-              <a:rPr sz="1300" b="0">
-                <a:solidFill>
-                  <a:srgbClr val="4A5163"/>
-                </a:solidFill>
-                <a:latin typeface="Arial"/>
-              </a:rPr>
-              <a:t>Owner Home: '1 thing to handle today' — the swap, its effect on both workers, and one Approve button</a:t>
             </a:r>
           </a:p>
         </p:txBody>
@@ -5807,7 +5951,7 @@
                 </a:solidFill>
                 <a:latin typeface="Arial"/>
               </a:rPr>
-              <a:t>Month end: payroll with legal checks</a:t>
+              <a:t>The owner decides on one card</a:t>
             </a:r>
           </a:p>
         </p:txBody>
@@ -5846,14 +5990,14 @@
                 </a:solidFill>
                 <a:latin typeface="Arial"/>
               </a:rPr>
-              <a:t>13 / 15   ·   Minkyung Kim</a:t>
+              <a:t>13 / 16   ·   Minkyung Kim</a:t>
             </a:r>
           </a:p>
         </p:txBody>
       </p:sp>
       <p:pic>
         <p:nvPicPr>
-          <p:cNvPr id="5" name="Picture 4" descr="ui-10-payroll.png"/>
+          <p:cNvPr id="5" name="Picture 4" descr="ui-06-approval.png"/>
           <p:cNvPicPr>
             <a:picLocks noChangeAspect="1"/>
           </p:cNvPicPr>
@@ -5867,8 +6011,8 @@
         </p:blipFill>
         <p:spPr>
           <a:xfrm>
-            <a:off x="3192840" y="1250000"/>
-            <a:ext cx="5806320" cy="4450000"/>
+            <a:off x="2931556" y="1250000"/>
+            <a:ext cx="6328888" cy="4450000"/>
           </a:xfrm>
           <a:prstGeom prst="rect">
             <a:avLst/>
@@ -5909,7 +6053,7 @@
                 </a:solidFill>
                 <a:latin typeface="Arial"/>
               </a:rPr>
-              <a:t>Doyun's wage is below the 2026 minimum: 'Confirm September pay' stays disabled, with the reason, until acknowledged</a:t>
+              <a:t>Owner Home: '1 thing to handle today' — the swap, its effect on both workers, and one Approve button</a:t>
             </a:r>
           </a:p>
         </p:txBody>
@@ -6010,7 +6154,7 @@
                 </a:solidFill>
                 <a:latin typeface="Arial"/>
               </a:rPr>
-              <a:t>Testing</a:t>
+              <a:t>Month end: payroll with legal checks</a:t>
             </a:r>
           </a:p>
         </p:txBody>
@@ -6049,50 +6193,35 @@
                 </a:solidFill>
                 <a:latin typeface="Arial"/>
               </a:rPr>
-              <a:t>14 / 15   ·   Minkyung Kim</a:t>
-            </a:r>
-          </a:p>
-        </p:txBody>
-      </p:sp>
-      <p:sp>
-        <p:nvSpPr>
-          <p:cNvPr id="5" name="TextBox 4"/>
-          <p:cNvSpPr txBox="1"/>
-          <p:nvPr/>
-        </p:nvSpPr>
-        <p:spPr>
-          <a:xfrm>
-            <a:off x="640000" y="1450000"/>
-            <a:ext cx="3437333" cy="900000"/>
-          </a:xfrm>
-          <a:prstGeom prst="rect">
-            <a:avLst/>
-          </a:prstGeom>
-          <a:noFill/>
-        </p:spPr>
-        <p:txBody>
-          <a:bodyPr wrap="square">
-            <a:spAutoFit/>
-          </a:bodyPr>
-          <a:lstStyle/>
-          <a:p>
-            <a:pPr algn="l">
-              <a:spcAft>
-                <a:spcPts val="2400"/>
-              </a:spcAft>
-            </a:pPr>
-            <a:r>
-              <a:rPr sz="4800" b="1">
-                <a:solidFill>
-                  <a:srgbClr val="2B5BD7"/>
-                </a:solidFill>
-                <a:latin typeface="Arial"/>
-              </a:rPr>
-              <a:t>77/77</a:t>
-            </a:r>
-          </a:p>
-        </p:txBody>
-      </p:sp>
+              <a:t>14 / 16   ·   Minkyung Kim</a:t>
+            </a:r>
+          </a:p>
+        </p:txBody>
+      </p:sp>
+      <p:pic>
+        <p:nvPicPr>
+          <p:cNvPr id="5" name="Picture 4" descr="ui-10-payroll.png"/>
+          <p:cNvPicPr>
+            <a:picLocks noChangeAspect="1"/>
+          </p:cNvPicPr>
+          <p:nvPr/>
+        </p:nvPicPr>
+        <p:blipFill>
+          <a:blip r:embed="rId2"/>
+          <a:stretch>
+            <a:fillRect/>
+          </a:stretch>
+        </p:blipFill>
+        <p:spPr>
+          <a:xfrm>
+            <a:off x="3192840" y="1250000"/>
+            <a:ext cx="5806320" cy="4450000"/>
+          </a:xfrm>
+          <a:prstGeom prst="rect">
+            <a:avLst/>
+          </a:prstGeom>
+        </p:spPr>
+      </p:pic>
       <p:sp>
         <p:nvSpPr>
           <p:cNvPr id="6" name="TextBox 5"/>
@@ -6101,47 +6230,8 @@
         </p:nvSpPr>
         <p:spPr>
           <a:xfrm>
-            <a:off x="640000" y="2350000"/>
-            <a:ext cx="3437333" cy="400000"/>
-          </a:xfrm>
-          <a:prstGeom prst="rect">
-            <a:avLst/>
-          </a:prstGeom>
-          <a:noFill/>
-        </p:spPr>
-        <p:txBody>
-          <a:bodyPr wrap="square">
-            <a:spAutoFit/>
-          </a:bodyPr>
-          <a:lstStyle/>
-          <a:p>
-            <a:pPr algn="l">
-              <a:spcAft>
-                <a:spcPts val="900"/>
-              </a:spcAft>
-            </a:pPr>
-            <a:r>
-              <a:rPr sz="1800" b="1">
-                <a:solidFill>
-                  <a:srgbClr val="1C2230"/>
-                </a:solidFill>
-                <a:latin typeface="Arial"/>
-              </a:rPr>
-              <a:t>tests pass</a:t>
-            </a:r>
-          </a:p>
-        </p:txBody>
-      </p:sp>
-      <p:sp>
-        <p:nvSpPr>
-          <p:cNvPr id="7" name="TextBox 6"/>
-          <p:cNvSpPr txBox="1"/>
-          <p:nvPr/>
-        </p:nvSpPr>
-        <p:spPr>
-          <a:xfrm>
-            <a:off x="640000" y="2750000"/>
-            <a:ext cx="3437333" cy="500000"/>
+            <a:off x="640000" y="5750000"/>
+            <a:ext cx="10912000" cy="400000"/>
           </a:xfrm>
           <a:prstGeom prst="rect">
             <a:avLst/>
@@ -6166,475 +6256,7 @@
                 </a:solidFill>
                 <a:latin typeface="Arial"/>
               </a:rPr>
-              <a:t>npm test, Node test runner</a:t>
-            </a:r>
-          </a:p>
-        </p:txBody>
-      </p:sp>
-      <p:sp>
-        <p:nvSpPr>
-          <p:cNvPr id="8" name="TextBox 7"/>
-          <p:cNvSpPr txBox="1"/>
-          <p:nvPr/>
-        </p:nvSpPr>
-        <p:spPr>
-          <a:xfrm>
-            <a:off x="4277333" y="1450000"/>
-            <a:ext cx="3437333" cy="900000"/>
-          </a:xfrm>
-          <a:prstGeom prst="rect">
-            <a:avLst/>
-          </a:prstGeom>
-          <a:noFill/>
-        </p:spPr>
-        <p:txBody>
-          <a:bodyPr wrap="square">
-            <a:spAutoFit/>
-          </a:bodyPr>
-          <a:lstStyle/>
-          <a:p>
-            <a:pPr algn="l">
-              <a:spcAft>
-                <a:spcPts val="2400"/>
-              </a:spcAft>
-            </a:pPr>
-            <a:r>
-              <a:rPr sz="4800" b="1">
-                <a:solidFill>
-                  <a:srgbClr val="2B5BD7"/>
-                </a:solidFill>
-                <a:latin typeface="Arial"/>
-              </a:rPr>
-              <a:t>12/12</a:t>
-            </a:r>
-          </a:p>
-        </p:txBody>
-      </p:sp>
-      <p:sp>
-        <p:nvSpPr>
-          <p:cNvPr id="9" name="TextBox 8"/>
-          <p:cNvSpPr txBox="1"/>
-          <p:nvPr/>
-        </p:nvSpPr>
-        <p:spPr>
-          <a:xfrm>
-            <a:off x="4277333" y="2350000"/>
-            <a:ext cx="3437333" cy="400000"/>
-          </a:xfrm>
-          <a:prstGeom prst="rect">
-            <a:avLst/>
-          </a:prstGeom>
-          <a:noFill/>
-        </p:spPr>
-        <p:txBody>
-          <a:bodyPr wrap="square">
-            <a:spAutoFit/>
-          </a:bodyPr>
-          <a:lstStyle/>
-          <a:p>
-            <a:pPr algn="l">
-              <a:spcAft>
-                <a:spcPts val="900"/>
-              </a:spcAft>
-            </a:pPr>
-            <a:r>
-              <a:rPr sz="1800" b="1">
-                <a:solidFill>
-                  <a:srgbClr val="1C2230"/>
-                </a:solidFill>
-                <a:latin typeface="Arial"/>
-              </a:rPr>
-              <a:t>business rules tested</a:t>
-            </a:r>
-          </a:p>
-        </p:txBody>
-      </p:sp>
-      <p:sp>
-        <p:nvSpPr>
-          <p:cNvPr id="10" name="TextBox 9"/>
-          <p:cNvSpPr txBox="1"/>
-          <p:nvPr/>
-        </p:nvSpPr>
-        <p:spPr>
-          <a:xfrm>
-            <a:off x="4277333" y="2750000"/>
-            <a:ext cx="3437333" cy="500000"/>
-          </a:xfrm>
-          <a:prstGeom prst="rect">
-            <a:avLst/>
-          </a:prstGeom>
-          <a:noFill/>
-        </p:spPr>
-        <p:txBody>
-          <a:bodyPr wrap="square">
-            <a:spAutoFit/>
-          </a:bodyPr>
-          <a:lstStyle/>
-          <a:p>
-            <a:pPr algn="l">
-              <a:spcAft>
-                <a:spcPts val="650"/>
-              </a:spcAft>
-            </a:pPr>
-            <a:r>
-              <a:rPr sz="1300" b="0">
-                <a:solidFill>
-                  <a:srgbClr val="4A5163"/>
-                </a:solidFill>
-                <a:latin typeface="Arial"/>
-              </a:rPr>
-              <a:t>every BR has ≥ 1 test</a:t>
-            </a:r>
-          </a:p>
-        </p:txBody>
-      </p:sp>
-      <p:sp>
-        <p:nvSpPr>
-          <p:cNvPr id="11" name="TextBox 10"/>
-          <p:cNvSpPr txBox="1"/>
-          <p:nvPr/>
-        </p:nvSpPr>
-        <p:spPr>
-          <a:xfrm>
-            <a:off x="7914666" y="1450000"/>
-            <a:ext cx="3437333" cy="900000"/>
-          </a:xfrm>
-          <a:prstGeom prst="rect">
-            <a:avLst/>
-          </a:prstGeom>
-          <a:noFill/>
-        </p:spPr>
-        <p:txBody>
-          <a:bodyPr wrap="square">
-            <a:spAutoFit/>
-          </a:bodyPr>
-          <a:lstStyle/>
-          <a:p>
-            <a:pPr algn="l">
-              <a:spcAft>
-                <a:spcPts val="2400"/>
-              </a:spcAft>
-            </a:pPr>
-            <a:r>
-              <a:rPr sz="4800" b="1">
-                <a:solidFill>
-                  <a:srgbClr val="2B5BD7"/>
-                </a:solidFill>
-                <a:latin typeface="Arial"/>
-              </a:rPr>
-              <a:t>77/77</a:t>
-            </a:r>
-          </a:p>
-        </p:txBody>
-      </p:sp>
-      <p:sp>
-        <p:nvSpPr>
-          <p:cNvPr id="12" name="TextBox 11"/>
-          <p:cNvSpPr txBox="1"/>
-          <p:nvPr/>
-        </p:nvSpPr>
-        <p:spPr>
-          <a:xfrm>
-            <a:off x="7914666" y="2350000"/>
-            <a:ext cx="3437333" cy="400000"/>
-          </a:xfrm>
-          <a:prstGeom prst="rect">
-            <a:avLst/>
-          </a:prstGeom>
-          <a:noFill/>
-        </p:spPr>
-        <p:txBody>
-          <a:bodyPr wrap="square">
-            <a:spAutoFit/>
-          </a:bodyPr>
-          <a:lstStyle/>
-          <a:p>
-            <a:pPr algn="l">
-              <a:spcAft>
-                <a:spcPts val="900"/>
-              </a:spcAft>
-            </a:pPr>
-            <a:r>
-              <a:rPr sz="1800" b="1">
-                <a:solidFill>
-                  <a:srgbClr val="1C2230"/>
-                </a:solidFill>
-                <a:latin typeface="Arial"/>
-              </a:rPr>
-              <a:t>tests pass in a clean rebuild</a:t>
-            </a:r>
-          </a:p>
-        </p:txBody>
-      </p:sp>
-      <p:sp>
-        <p:nvSpPr>
-          <p:cNvPr id="13" name="TextBox 12"/>
-          <p:cNvSpPr txBox="1"/>
-          <p:nvPr/>
-        </p:nvSpPr>
-        <p:spPr>
-          <a:xfrm>
-            <a:off x="7914666" y="2750000"/>
-            <a:ext cx="3437333" cy="500000"/>
-          </a:xfrm>
-          <a:prstGeom prst="rect">
-            <a:avLst/>
-          </a:prstGeom>
-          <a:noFill/>
-        </p:spPr>
-        <p:txBody>
-          <a:bodyPr wrap="square">
-            <a:spAutoFit/>
-          </a:bodyPr>
-          <a:lstStyle/>
-          <a:p>
-            <a:pPr algn="l">
-              <a:spcAft>
-                <a:spcPts val="650"/>
-              </a:spcAft>
-            </a:pPr>
-            <a:r>
-              <a:rPr sz="1300" b="0">
-                <a:solidFill>
-                  <a:srgbClr val="4A5163"/>
-                </a:solidFill>
-                <a:latin typeface="Arial"/>
-              </a:rPr>
-              <a:t>prompt v5 re-run in an empty folder</a:t>
-            </a:r>
-          </a:p>
-        </p:txBody>
-      </p:sp>
-      <p:sp>
-        <p:nvSpPr>
-          <p:cNvPr id="14" name="TextBox 13"/>
-          <p:cNvSpPr txBox="1"/>
-          <p:nvPr/>
-        </p:nvSpPr>
-        <p:spPr>
-          <a:xfrm>
-            <a:off x="640000" y="3450000"/>
-            <a:ext cx="3437333" cy="900000"/>
-          </a:xfrm>
-          <a:prstGeom prst="rect">
-            <a:avLst/>
-          </a:prstGeom>
-          <a:noFill/>
-        </p:spPr>
-        <p:txBody>
-          <a:bodyPr wrap="square">
-            <a:spAutoFit/>
-          </a:bodyPr>
-          <a:lstStyle/>
-          <a:p>
-            <a:pPr algn="l">
-              <a:spcAft>
-                <a:spcPts val="2400"/>
-              </a:spcAft>
-            </a:pPr>
-            <a:r>
-              <a:rPr sz="4800" b="1">
-                <a:solidFill>
-                  <a:srgbClr val="2B5BD7"/>
-                </a:solidFill>
-                <a:latin typeface="Arial"/>
-              </a:rPr>
-              <a:t>21/21</a:t>
-            </a:r>
-          </a:p>
-        </p:txBody>
-      </p:sp>
-      <p:sp>
-        <p:nvSpPr>
-          <p:cNvPr id="15" name="TextBox 14"/>
-          <p:cNvSpPr txBox="1"/>
-          <p:nvPr/>
-        </p:nvSpPr>
-        <p:spPr>
-          <a:xfrm>
-            <a:off x="640000" y="4350000"/>
-            <a:ext cx="3437333" cy="400000"/>
-          </a:xfrm>
-          <a:prstGeom prst="rect">
-            <a:avLst/>
-          </a:prstGeom>
-          <a:noFill/>
-        </p:spPr>
-        <p:txBody>
-          <a:bodyPr wrap="square">
-            <a:spAutoFit/>
-          </a:bodyPr>
-          <a:lstStyle/>
-          <a:p>
-            <a:pPr algn="l">
-              <a:spcAft>
-                <a:spcPts val="900"/>
-              </a:spcAft>
-            </a:pPr>
-            <a:r>
-              <a:rPr sz="1800" b="1">
-                <a:solidFill>
-                  <a:srgbClr val="1C2230"/>
-                </a:solidFill>
-                <a:latin typeface="Arial"/>
-              </a:rPr>
-              <a:t>FRs traced</a:t>
-            </a:r>
-          </a:p>
-        </p:txBody>
-      </p:sp>
-      <p:sp>
-        <p:nvSpPr>
-          <p:cNvPr id="16" name="TextBox 15"/>
-          <p:cNvSpPr txBox="1"/>
-          <p:nvPr/>
-        </p:nvSpPr>
-        <p:spPr>
-          <a:xfrm>
-            <a:off x="640000" y="4750000"/>
-            <a:ext cx="3437333" cy="500000"/>
-          </a:xfrm>
-          <a:prstGeom prst="rect">
-            <a:avLst/>
-          </a:prstGeom>
-          <a:noFill/>
-        </p:spPr>
-        <p:txBody>
-          <a:bodyPr wrap="square">
-            <a:spAutoFit/>
-          </a:bodyPr>
-          <a:lstStyle/>
-          <a:p>
-            <a:pPr algn="l">
-              <a:spcAft>
-                <a:spcPts val="650"/>
-              </a:spcAft>
-            </a:pPr>
-            <a:r>
-              <a:rPr sz="1300" b="0">
-                <a:solidFill>
-                  <a:srgbClr val="4A5163"/>
-                </a:solidFill>
-                <a:latin typeface="Arial"/>
-              </a:rPr>
-              <a:t>FR → UC → screen → function → test</a:t>
-            </a:r>
-          </a:p>
-        </p:txBody>
-      </p:sp>
-      <p:sp>
-        <p:nvSpPr>
-          <p:cNvPr id="17" name="TextBox 16"/>
-          <p:cNvSpPr txBox="1"/>
-          <p:nvPr/>
-        </p:nvSpPr>
-        <p:spPr>
-          <a:xfrm>
-            <a:off x="4277333" y="3450000"/>
-            <a:ext cx="3437333" cy="900000"/>
-          </a:xfrm>
-          <a:prstGeom prst="rect">
-            <a:avLst/>
-          </a:prstGeom>
-          <a:noFill/>
-        </p:spPr>
-        <p:txBody>
-          <a:bodyPr wrap="square">
-            <a:spAutoFit/>
-          </a:bodyPr>
-          <a:lstStyle/>
-          <a:p>
-            <a:pPr algn="l">
-              <a:spcAft>
-                <a:spcPts val="2400"/>
-              </a:spcAft>
-            </a:pPr>
-            <a:r>
-              <a:rPr sz="4800" b="1">
-                <a:solidFill>
-                  <a:srgbClr val="2B5BD7"/>
-                </a:solidFill>
-                <a:latin typeface="Arial"/>
-              </a:rPr>
-              <a:t>2</a:t>
-            </a:r>
-          </a:p>
-        </p:txBody>
-      </p:sp>
-      <p:sp>
-        <p:nvSpPr>
-          <p:cNvPr id="18" name="TextBox 17"/>
-          <p:cNvSpPr txBox="1"/>
-          <p:nvPr/>
-        </p:nvSpPr>
-        <p:spPr>
-          <a:xfrm>
-            <a:off x="4277333" y="4350000"/>
-            <a:ext cx="3437333" cy="400000"/>
-          </a:xfrm>
-          <a:prstGeom prst="rect">
-            <a:avLst/>
-          </a:prstGeom>
-          <a:noFill/>
-        </p:spPr>
-        <p:txBody>
-          <a:bodyPr wrap="square">
-            <a:spAutoFit/>
-          </a:bodyPr>
-          <a:lstStyle/>
-          <a:p>
-            <a:pPr algn="l">
-              <a:spcAft>
-                <a:spcPts val="900"/>
-              </a:spcAft>
-            </a:pPr>
-            <a:r>
-              <a:rPr sz="1800" b="1">
-                <a:solidFill>
-                  <a:srgbClr val="1C2230"/>
-                </a:solidFill>
-                <a:latin typeface="Arial"/>
-              </a:rPr>
-              <a:t>screen widths</a:t>
-            </a:r>
-          </a:p>
-        </p:txBody>
-      </p:sp>
-      <p:sp>
-        <p:nvSpPr>
-          <p:cNvPr id="19" name="TextBox 18"/>
-          <p:cNvSpPr txBox="1"/>
-          <p:nvPr/>
-        </p:nvSpPr>
-        <p:spPr>
-          <a:xfrm>
-            <a:off x="4277333" y="4750000"/>
-            <a:ext cx="3437333" cy="500000"/>
-          </a:xfrm>
-          <a:prstGeom prst="rect">
-            <a:avLst/>
-          </a:prstGeom>
-          <a:noFill/>
-        </p:spPr>
-        <p:txBody>
-          <a:bodyPr wrap="square">
-            <a:spAutoFit/>
-          </a:bodyPr>
-          <a:lstStyle/>
-          <a:p>
-            <a:pPr algn="l">
-              <a:spcAft>
-                <a:spcPts val="650"/>
-              </a:spcAft>
-            </a:pPr>
-            <a:r>
-              <a:rPr sz="1300" b="0">
-                <a:solidFill>
-                  <a:srgbClr val="4A5163"/>
-                </a:solidFill>
-                <a:latin typeface="Arial"/>
-              </a:rPr>
-              <a:t>360 px and 1440 px, no horizontal scroll</a:t>
+              <a:t>Doyun's wage is below the 2026 minimum: 'Confirm September pay' stays disabled, with the reason, until acknowledged</a:t>
             </a:r>
           </a:p>
         </p:txBody>
@@ -6735,7 +6357,7 @@
                 </a:solidFill>
                 <a:latin typeface="Arial"/>
               </a:rPr>
-              <a:t>Results and limits</a:t>
+              <a:t>Testing</a:t>
             </a:r>
           </a:p>
         </p:txBody>
@@ -6774,7 +6396,732 @@
                 </a:solidFill>
                 <a:latin typeface="Arial"/>
               </a:rPr>
-              <a:t>15 / 15   ·   Minkyung Kim</a:t>
+              <a:t>15 / 16   ·   Minkyung Kim</a:t>
+            </a:r>
+          </a:p>
+        </p:txBody>
+      </p:sp>
+      <p:sp>
+        <p:nvSpPr>
+          <p:cNvPr id="5" name="TextBox 4"/>
+          <p:cNvSpPr txBox="1"/>
+          <p:nvPr/>
+        </p:nvSpPr>
+        <p:spPr>
+          <a:xfrm>
+            <a:off x="640000" y="1450000"/>
+            <a:ext cx="3437333" cy="900000"/>
+          </a:xfrm>
+          <a:prstGeom prst="rect">
+            <a:avLst/>
+          </a:prstGeom>
+          <a:noFill/>
+        </p:spPr>
+        <p:txBody>
+          <a:bodyPr wrap="square">
+            <a:spAutoFit/>
+          </a:bodyPr>
+          <a:lstStyle/>
+          <a:p>
+            <a:pPr algn="l">
+              <a:spcAft>
+                <a:spcPts val="2400"/>
+              </a:spcAft>
+            </a:pPr>
+            <a:r>
+              <a:rPr sz="4800" b="1">
+                <a:solidFill>
+                  <a:srgbClr val="2B5BD7"/>
+                </a:solidFill>
+                <a:latin typeface="Arial"/>
+              </a:rPr>
+              <a:t>84/84</a:t>
+            </a:r>
+          </a:p>
+        </p:txBody>
+      </p:sp>
+      <p:sp>
+        <p:nvSpPr>
+          <p:cNvPr id="6" name="TextBox 5"/>
+          <p:cNvSpPr txBox="1"/>
+          <p:nvPr/>
+        </p:nvSpPr>
+        <p:spPr>
+          <a:xfrm>
+            <a:off x="640000" y="2350000"/>
+            <a:ext cx="3437333" cy="400000"/>
+          </a:xfrm>
+          <a:prstGeom prst="rect">
+            <a:avLst/>
+          </a:prstGeom>
+          <a:noFill/>
+        </p:spPr>
+        <p:txBody>
+          <a:bodyPr wrap="square">
+            <a:spAutoFit/>
+          </a:bodyPr>
+          <a:lstStyle/>
+          <a:p>
+            <a:pPr algn="l">
+              <a:spcAft>
+                <a:spcPts val="900"/>
+              </a:spcAft>
+            </a:pPr>
+            <a:r>
+              <a:rPr sz="1800" b="1">
+                <a:solidFill>
+                  <a:srgbClr val="1C2230"/>
+                </a:solidFill>
+                <a:latin typeface="Arial"/>
+              </a:rPr>
+              <a:t>tests pass</a:t>
+            </a:r>
+          </a:p>
+        </p:txBody>
+      </p:sp>
+      <p:sp>
+        <p:nvSpPr>
+          <p:cNvPr id="7" name="TextBox 6"/>
+          <p:cNvSpPr txBox="1"/>
+          <p:nvPr/>
+        </p:nvSpPr>
+        <p:spPr>
+          <a:xfrm>
+            <a:off x="640000" y="2750000"/>
+            <a:ext cx="3437333" cy="500000"/>
+          </a:xfrm>
+          <a:prstGeom prst="rect">
+            <a:avLst/>
+          </a:prstGeom>
+          <a:noFill/>
+        </p:spPr>
+        <p:txBody>
+          <a:bodyPr wrap="square">
+            <a:spAutoFit/>
+          </a:bodyPr>
+          <a:lstStyle/>
+          <a:p>
+            <a:pPr algn="l">
+              <a:spcAft>
+                <a:spcPts val="650"/>
+              </a:spcAft>
+            </a:pPr>
+            <a:r>
+              <a:rPr sz="1300" b="0">
+                <a:solidFill>
+                  <a:srgbClr val="4A5163"/>
+                </a:solidFill>
+                <a:latin typeface="Arial"/>
+              </a:rPr>
+              <a:t>npm test, Node test runner</a:t>
+            </a:r>
+          </a:p>
+        </p:txBody>
+      </p:sp>
+      <p:sp>
+        <p:nvSpPr>
+          <p:cNvPr id="8" name="TextBox 7"/>
+          <p:cNvSpPr txBox="1"/>
+          <p:nvPr/>
+        </p:nvSpPr>
+        <p:spPr>
+          <a:xfrm>
+            <a:off x="4277333" y="1450000"/>
+            <a:ext cx="3437333" cy="900000"/>
+          </a:xfrm>
+          <a:prstGeom prst="rect">
+            <a:avLst/>
+          </a:prstGeom>
+          <a:noFill/>
+        </p:spPr>
+        <p:txBody>
+          <a:bodyPr wrap="square">
+            <a:spAutoFit/>
+          </a:bodyPr>
+          <a:lstStyle/>
+          <a:p>
+            <a:pPr algn="l">
+              <a:spcAft>
+                <a:spcPts val="2400"/>
+              </a:spcAft>
+            </a:pPr>
+            <a:r>
+              <a:rPr sz="4800" b="1">
+                <a:solidFill>
+                  <a:srgbClr val="2B5BD7"/>
+                </a:solidFill>
+                <a:latin typeface="Arial"/>
+              </a:rPr>
+              <a:t>13/13</a:t>
+            </a:r>
+          </a:p>
+        </p:txBody>
+      </p:sp>
+      <p:sp>
+        <p:nvSpPr>
+          <p:cNvPr id="9" name="TextBox 8"/>
+          <p:cNvSpPr txBox="1"/>
+          <p:nvPr/>
+        </p:nvSpPr>
+        <p:spPr>
+          <a:xfrm>
+            <a:off x="4277333" y="2350000"/>
+            <a:ext cx="3437333" cy="400000"/>
+          </a:xfrm>
+          <a:prstGeom prst="rect">
+            <a:avLst/>
+          </a:prstGeom>
+          <a:noFill/>
+        </p:spPr>
+        <p:txBody>
+          <a:bodyPr wrap="square">
+            <a:spAutoFit/>
+          </a:bodyPr>
+          <a:lstStyle/>
+          <a:p>
+            <a:pPr algn="l">
+              <a:spcAft>
+                <a:spcPts val="900"/>
+              </a:spcAft>
+            </a:pPr>
+            <a:r>
+              <a:rPr sz="1800" b="1">
+                <a:solidFill>
+                  <a:srgbClr val="1C2230"/>
+                </a:solidFill>
+                <a:latin typeface="Arial"/>
+              </a:rPr>
+              <a:t>business rules tested</a:t>
+            </a:r>
+          </a:p>
+        </p:txBody>
+      </p:sp>
+      <p:sp>
+        <p:nvSpPr>
+          <p:cNvPr id="10" name="TextBox 9"/>
+          <p:cNvSpPr txBox="1"/>
+          <p:nvPr/>
+        </p:nvSpPr>
+        <p:spPr>
+          <a:xfrm>
+            <a:off x="4277333" y="2750000"/>
+            <a:ext cx="3437333" cy="500000"/>
+          </a:xfrm>
+          <a:prstGeom prst="rect">
+            <a:avLst/>
+          </a:prstGeom>
+          <a:noFill/>
+        </p:spPr>
+        <p:txBody>
+          <a:bodyPr wrap="square">
+            <a:spAutoFit/>
+          </a:bodyPr>
+          <a:lstStyle/>
+          <a:p>
+            <a:pPr algn="l">
+              <a:spcAft>
+                <a:spcPts val="650"/>
+              </a:spcAft>
+            </a:pPr>
+            <a:r>
+              <a:rPr sz="1300" b="0">
+                <a:solidFill>
+                  <a:srgbClr val="4A5163"/>
+                </a:solidFill>
+                <a:latin typeface="Arial"/>
+              </a:rPr>
+              <a:t>every BR has ≥ 1 test</a:t>
+            </a:r>
+          </a:p>
+        </p:txBody>
+      </p:sp>
+      <p:sp>
+        <p:nvSpPr>
+          <p:cNvPr id="11" name="TextBox 10"/>
+          <p:cNvSpPr txBox="1"/>
+          <p:nvPr/>
+        </p:nvSpPr>
+        <p:spPr>
+          <a:xfrm>
+            <a:off x="7914666" y="1450000"/>
+            <a:ext cx="3437333" cy="900000"/>
+          </a:xfrm>
+          <a:prstGeom prst="rect">
+            <a:avLst/>
+          </a:prstGeom>
+          <a:noFill/>
+        </p:spPr>
+        <p:txBody>
+          <a:bodyPr wrap="square">
+            <a:spAutoFit/>
+          </a:bodyPr>
+          <a:lstStyle/>
+          <a:p>
+            <a:pPr algn="l">
+              <a:spcAft>
+                <a:spcPts val="2400"/>
+              </a:spcAft>
+            </a:pPr>
+            <a:r>
+              <a:rPr sz="4800" b="1">
+                <a:solidFill>
+                  <a:srgbClr val="2B5BD7"/>
+                </a:solidFill>
+                <a:latin typeface="Arial"/>
+              </a:rPr>
+              <a:t>77/77</a:t>
+            </a:r>
+          </a:p>
+        </p:txBody>
+      </p:sp>
+      <p:sp>
+        <p:nvSpPr>
+          <p:cNvPr id="12" name="TextBox 11"/>
+          <p:cNvSpPr txBox="1"/>
+          <p:nvPr/>
+        </p:nvSpPr>
+        <p:spPr>
+          <a:xfrm>
+            <a:off x="7914666" y="2350000"/>
+            <a:ext cx="3437333" cy="400000"/>
+          </a:xfrm>
+          <a:prstGeom prst="rect">
+            <a:avLst/>
+          </a:prstGeom>
+          <a:noFill/>
+        </p:spPr>
+        <p:txBody>
+          <a:bodyPr wrap="square">
+            <a:spAutoFit/>
+          </a:bodyPr>
+          <a:lstStyle/>
+          <a:p>
+            <a:pPr algn="l">
+              <a:spcAft>
+                <a:spcPts val="900"/>
+              </a:spcAft>
+            </a:pPr>
+            <a:r>
+              <a:rPr sz="1800" b="1">
+                <a:solidFill>
+                  <a:srgbClr val="1C2230"/>
+                </a:solidFill>
+                <a:latin typeface="Arial"/>
+              </a:rPr>
+              <a:t>tests pass in a clean rebuild</a:t>
+            </a:r>
+          </a:p>
+        </p:txBody>
+      </p:sp>
+      <p:sp>
+        <p:nvSpPr>
+          <p:cNvPr id="13" name="TextBox 12"/>
+          <p:cNvSpPr txBox="1"/>
+          <p:nvPr/>
+        </p:nvSpPr>
+        <p:spPr>
+          <a:xfrm>
+            <a:off x="7914666" y="2750000"/>
+            <a:ext cx="3437333" cy="500000"/>
+          </a:xfrm>
+          <a:prstGeom prst="rect">
+            <a:avLst/>
+          </a:prstGeom>
+          <a:noFill/>
+        </p:spPr>
+        <p:txBody>
+          <a:bodyPr wrap="square">
+            <a:spAutoFit/>
+          </a:bodyPr>
+          <a:lstStyle/>
+          <a:p>
+            <a:pPr algn="l">
+              <a:spcAft>
+                <a:spcPts val="650"/>
+              </a:spcAft>
+            </a:pPr>
+            <a:r>
+              <a:rPr sz="1300" b="0">
+                <a:solidFill>
+                  <a:srgbClr val="4A5163"/>
+                </a:solidFill>
+                <a:latin typeface="Arial"/>
+              </a:rPr>
+              <a:t>prompt v5 re-run in an empty folder</a:t>
+            </a:r>
+          </a:p>
+        </p:txBody>
+      </p:sp>
+      <p:sp>
+        <p:nvSpPr>
+          <p:cNvPr id="14" name="TextBox 13"/>
+          <p:cNvSpPr txBox="1"/>
+          <p:nvPr/>
+        </p:nvSpPr>
+        <p:spPr>
+          <a:xfrm>
+            <a:off x="640000" y="3450000"/>
+            <a:ext cx="3437333" cy="900000"/>
+          </a:xfrm>
+          <a:prstGeom prst="rect">
+            <a:avLst/>
+          </a:prstGeom>
+          <a:noFill/>
+        </p:spPr>
+        <p:txBody>
+          <a:bodyPr wrap="square">
+            <a:spAutoFit/>
+          </a:bodyPr>
+          <a:lstStyle/>
+          <a:p>
+            <a:pPr algn="l">
+              <a:spcAft>
+                <a:spcPts val="2400"/>
+              </a:spcAft>
+            </a:pPr>
+            <a:r>
+              <a:rPr sz="4800" b="1">
+                <a:solidFill>
+                  <a:srgbClr val="2B5BD7"/>
+                </a:solidFill>
+                <a:latin typeface="Arial"/>
+              </a:rPr>
+              <a:t>21/21</a:t>
+            </a:r>
+          </a:p>
+        </p:txBody>
+      </p:sp>
+      <p:sp>
+        <p:nvSpPr>
+          <p:cNvPr id="15" name="TextBox 14"/>
+          <p:cNvSpPr txBox="1"/>
+          <p:nvPr/>
+        </p:nvSpPr>
+        <p:spPr>
+          <a:xfrm>
+            <a:off x="640000" y="4350000"/>
+            <a:ext cx="3437333" cy="400000"/>
+          </a:xfrm>
+          <a:prstGeom prst="rect">
+            <a:avLst/>
+          </a:prstGeom>
+          <a:noFill/>
+        </p:spPr>
+        <p:txBody>
+          <a:bodyPr wrap="square">
+            <a:spAutoFit/>
+          </a:bodyPr>
+          <a:lstStyle/>
+          <a:p>
+            <a:pPr algn="l">
+              <a:spcAft>
+                <a:spcPts val="900"/>
+              </a:spcAft>
+            </a:pPr>
+            <a:r>
+              <a:rPr sz="1800" b="1">
+                <a:solidFill>
+                  <a:srgbClr val="1C2230"/>
+                </a:solidFill>
+                <a:latin typeface="Arial"/>
+              </a:rPr>
+              <a:t>FRs traced</a:t>
+            </a:r>
+          </a:p>
+        </p:txBody>
+      </p:sp>
+      <p:sp>
+        <p:nvSpPr>
+          <p:cNvPr id="16" name="TextBox 15"/>
+          <p:cNvSpPr txBox="1"/>
+          <p:nvPr/>
+        </p:nvSpPr>
+        <p:spPr>
+          <a:xfrm>
+            <a:off x="640000" y="4750000"/>
+            <a:ext cx="3437333" cy="500000"/>
+          </a:xfrm>
+          <a:prstGeom prst="rect">
+            <a:avLst/>
+          </a:prstGeom>
+          <a:noFill/>
+        </p:spPr>
+        <p:txBody>
+          <a:bodyPr wrap="square">
+            <a:spAutoFit/>
+          </a:bodyPr>
+          <a:lstStyle/>
+          <a:p>
+            <a:pPr algn="l">
+              <a:spcAft>
+                <a:spcPts val="650"/>
+              </a:spcAft>
+            </a:pPr>
+            <a:r>
+              <a:rPr sz="1300" b="0">
+                <a:solidFill>
+                  <a:srgbClr val="4A5163"/>
+                </a:solidFill>
+                <a:latin typeface="Arial"/>
+              </a:rPr>
+              <a:t>FR → UC → screen → function → test</a:t>
+            </a:r>
+          </a:p>
+        </p:txBody>
+      </p:sp>
+      <p:sp>
+        <p:nvSpPr>
+          <p:cNvPr id="17" name="TextBox 16"/>
+          <p:cNvSpPr txBox="1"/>
+          <p:nvPr/>
+        </p:nvSpPr>
+        <p:spPr>
+          <a:xfrm>
+            <a:off x="4277333" y="3450000"/>
+            <a:ext cx="3437333" cy="900000"/>
+          </a:xfrm>
+          <a:prstGeom prst="rect">
+            <a:avLst/>
+          </a:prstGeom>
+          <a:noFill/>
+        </p:spPr>
+        <p:txBody>
+          <a:bodyPr wrap="square">
+            <a:spAutoFit/>
+          </a:bodyPr>
+          <a:lstStyle/>
+          <a:p>
+            <a:pPr algn="l">
+              <a:spcAft>
+                <a:spcPts val="2400"/>
+              </a:spcAft>
+            </a:pPr>
+            <a:r>
+              <a:rPr sz="4800" b="1">
+                <a:solidFill>
+                  <a:srgbClr val="2B5BD7"/>
+                </a:solidFill>
+                <a:latin typeface="Arial"/>
+              </a:rPr>
+              <a:t>2</a:t>
+            </a:r>
+          </a:p>
+        </p:txBody>
+      </p:sp>
+      <p:sp>
+        <p:nvSpPr>
+          <p:cNvPr id="18" name="TextBox 17"/>
+          <p:cNvSpPr txBox="1"/>
+          <p:nvPr/>
+        </p:nvSpPr>
+        <p:spPr>
+          <a:xfrm>
+            <a:off x="4277333" y="4350000"/>
+            <a:ext cx="3437333" cy="400000"/>
+          </a:xfrm>
+          <a:prstGeom prst="rect">
+            <a:avLst/>
+          </a:prstGeom>
+          <a:noFill/>
+        </p:spPr>
+        <p:txBody>
+          <a:bodyPr wrap="square">
+            <a:spAutoFit/>
+          </a:bodyPr>
+          <a:lstStyle/>
+          <a:p>
+            <a:pPr algn="l">
+              <a:spcAft>
+                <a:spcPts val="900"/>
+              </a:spcAft>
+            </a:pPr>
+            <a:r>
+              <a:rPr sz="1800" b="1">
+                <a:solidFill>
+                  <a:srgbClr val="1C2230"/>
+                </a:solidFill>
+                <a:latin typeface="Arial"/>
+              </a:rPr>
+              <a:t>screen widths</a:t>
+            </a:r>
+          </a:p>
+        </p:txBody>
+      </p:sp>
+      <p:sp>
+        <p:nvSpPr>
+          <p:cNvPr id="19" name="TextBox 18"/>
+          <p:cNvSpPr txBox="1"/>
+          <p:nvPr/>
+        </p:nvSpPr>
+        <p:spPr>
+          <a:xfrm>
+            <a:off x="4277333" y="4750000"/>
+            <a:ext cx="3437333" cy="500000"/>
+          </a:xfrm>
+          <a:prstGeom prst="rect">
+            <a:avLst/>
+          </a:prstGeom>
+          <a:noFill/>
+        </p:spPr>
+        <p:txBody>
+          <a:bodyPr wrap="square">
+            <a:spAutoFit/>
+          </a:bodyPr>
+          <a:lstStyle/>
+          <a:p>
+            <a:pPr algn="l">
+              <a:spcAft>
+                <a:spcPts val="650"/>
+              </a:spcAft>
+            </a:pPr>
+            <a:r>
+              <a:rPr sz="1300" b="0">
+                <a:solidFill>
+                  <a:srgbClr val="4A5163"/>
+                </a:solidFill>
+                <a:latin typeface="Arial"/>
+              </a:rPr>
+              <a:t>360 px and 1440 px, no horizontal scroll</a:t>
+            </a:r>
+          </a:p>
+        </p:txBody>
+      </p:sp>
+    </p:spTree>
+  </p:cSld>
+  <p:clrMapOvr>
+    <a:masterClrMapping/>
+  </p:clrMapOvr>
+</p:sld>
+</file>
+
+<file path=ppt/slides/slide16.xml><?xml version="1.0" encoding="utf-8"?>
+<p:sld xmlns:a="http://schemas.openxmlformats.org/drawingml/2006/main" xmlns:p="http://schemas.openxmlformats.org/presentationml/2006/main" xmlns:r="http://schemas.openxmlformats.org/officeDocument/2006/relationships">
+  <p:cSld>
+    <p:spTree>
+      <p:nvGrpSpPr>
+        <p:cNvPr id="1" name=""/>
+        <p:cNvGrpSpPr/>
+        <p:nvPr/>
+      </p:nvGrpSpPr>
+      <p:grpSpPr/>
+      <p:sp>
+        <p:nvSpPr>
+          <p:cNvPr id="2" name="Rectangle 1"/>
+          <p:cNvSpPr/>
+          <p:nvPr/>
+        </p:nvSpPr>
+        <p:spPr>
+          <a:xfrm>
+            <a:off x="0" y="0"/>
+            <a:ext cx="120000" cy="6858000"/>
+          </a:xfrm>
+          <a:prstGeom prst="rect">
+            <a:avLst/>
+          </a:prstGeom>
+          <a:solidFill>
+            <a:srgbClr val="1C2230"/>
+          </a:solidFill>
+          <a:ln>
+            <a:noFill/>
+          </a:ln>
+          <a:effectLst/>
+        </p:spPr>
+        <p:style>
+          <a:lnRef idx="1">
+            <a:schemeClr val="accent1"/>
+          </a:lnRef>
+          <a:fillRef idx="3">
+            <a:schemeClr val="accent1"/>
+          </a:fillRef>
+          <a:effectRef idx="2">
+            <a:schemeClr val="accent1"/>
+          </a:effectRef>
+          <a:fontRef idx="minor">
+            <a:schemeClr val="lt1"/>
+          </a:fontRef>
+        </p:style>
+        <p:txBody>
+          <a:bodyPr rtlCol="0" anchor="ctr"/>
+          <a:lstStyle/>
+          <a:p>
+            <a:pPr algn="ctr"/>
+          </a:p>
+        </p:txBody>
+      </p:sp>
+      <p:sp>
+        <p:nvSpPr>
+          <p:cNvPr id="3" name="TextBox 2"/>
+          <p:cNvSpPr txBox="1"/>
+          <p:nvPr/>
+        </p:nvSpPr>
+        <p:spPr>
+          <a:xfrm>
+            <a:off x="640000" y="430000"/>
+            <a:ext cx="10912000" cy="700000"/>
+          </a:xfrm>
+          <a:prstGeom prst="rect">
+            <a:avLst/>
+          </a:prstGeom>
+          <a:noFill/>
+        </p:spPr>
+        <p:txBody>
+          <a:bodyPr wrap="square">
+            <a:spAutoFit/>
+          </a:bodyPr>
+          <a:lstStyle/>
+          <a:p>
+            <a:pPr algn="l">
+              <a:spcAft>
+                <a:spcPts val="1500"/>
+              </a:spcAft>
+            </a:pPr>
+            <a:r>
+              <a:rPr sz="3000" b="1">
+                <a:solidFill>
+                  <a:srgbClr val="1C2230"/>
+                </a:solidFill>
+                <a:latin typeface="Arial"/>
+              </a:rPr>
+              <a:t>Results and limits</a:t>
+            </a:r>
+          </a:p>
+        </p:txBody>
+      </p:sp>
+      <p:sp>
+        <p:nvSpPr>
+          <p:cNvPr id="4" name="TextBox 3"/>
+          <p:cNvSpPr txBox="1"/>
+          <p:nvPr/>
+        </p:nvSpPr>
+        <p:spPr>
+          <a:xfrm>
+            <a:off x="640000" y="6338000"/>
+            <a:ext cx="10912000" cy="300000"/>
+          </a:xfrm>
+          <a:prstGeom prst="rect">
+            <a:avLst/>
+          </a:prstGeom>
+          <a:noFill/>
+        </p:spPr>
+        <p:txBody>
+          <a:bodyPr wrap="square">
+            <a:spAutoFit/>
+          </a:bodyPr>
+          <a:lstStyle/>
+          <a:p>
+            <a:pPr algn="l">
+              <a:spcAft>
+                <a:spcPts val="550"/>
+              </a:spcAft>
+            </a:pPr>
+            <a:r>
+              <a:rPr sz="1100" b="0">
+                <a:solidFill>
+                  <a:srgbClr val="4A5163"/>
+                </a:solidFill>
+                <a:latin typeface="Arial"/>
+              </a:rPr>
+              <a:t>16 / 16   ·   Minkyung Kim</a:t>
             </a:r>
           </a:p>
         </p:txBody>
@@ -6882,7 +7229,7 @@
                           </a:solidFill>
                           <a:latin typeface="Arial"/>
                         </a:rPr>
-                        <a:t>13 use cases · 12 tables · 5,380 lines of application code · 902 lines of tests</a:t>
+                        <a:t>12 use cases · 11 tables · 5,426 lines of application code · 1,051 lines of tests</a:t>
                       </a:r>
                     </a:p>
                   </a:txBody>
@@ -7124,7 +7471,7 @@
                 </a:solidFill>
                 <a:latin typeface="Arial"/>
               </a:rPr>
-              <a:t>2 / 15   ·   Hyewon Kim</a:t>
+              <a:t>2 / 16   ·   Hyewon Kim</a:t>
             </a:r>
           </a:p>
         </p:txBody>
@@ -7335,7 +7682,7 @@
                 </a:solidFill>
                 <a:latin typeface="Arial"/>
               </a:rPr>
-              <a:t>3 / 15   ·   Hyewon Kim</a:t>
+              <a:t>3 / 16   ·   Hyewon Kim</a:t>
             </a:r>
           </a:p>
         </p:txBody>
@@ -7958,7 +8305,7 @@
                 </a:solidFill>
                 <a:latin typeface="Arial"/>
               </a:rPr>
-              <a:t>4 / 15   ·   Hyewon Kim</a:t>
+              <a:t>4 / 16   ·   Hyewon Kim</a:t>
             </a:r>
           </a:p>
         </p:txBody>
@@ -8114,7 +8461,7 @@
                 </a:solidFill>
                 <a:latin typeface="Arial"/>
               </a:rPr>
-              <a:t>13</a:t>
+              <a:t>12</a:t>
             </a:r>
           </a:p>
         </p:txBody>
@@ -8192,7 +8539,7 @@
                 </a:solidFill>
                 <a:latin typeface="Arial"/>
               </a:rPr>
-              <a:t>9 core, all traced to screens</a:t>
+              <a:t>UC-02 retired in iteration 6</a:t>
             </a:r>
           </a:p>
         </p:txBody>
@@ -8309,7 +8656,7 @@
                 </a:solidFill>
                 <a:latin typeface="Arial"/>
               </a:rPr>
-              <a:t>FR-01 … FR-21</a:t>
+              <a:t>FR-01 … FR-22, FR-03 retired</a:t>
             </a:r>
           </a:p>
         </p:txBody>
@@ -8465,7 +8812,7 @@
                 </a:solidFill>
                 <a:latin typeface="Arial"/>
               </a:rPr>
-              <a:t>12</a:t>
+              <a:t>13</a:t>
             </a:r>
           </a:p>
         </p:txBody>
@@ -8543,7 +8890,7 @@
                 </a:solidFill>
                 <a:latin typeface="Arial"/>
               </a:rPr>
-              <a:t>BR-01 … BR-12, each tested</a:t>
+              <a:t>BR-01 … BR-13, each tested</a:t>
             </a:r>
           </a:p>
         </p:txBody>
@@ -8582,7 +8929,7 @@
                 </a:solidFill>
                 <a:latin typeface="Arial"/>
               </a:rPr>
-              <a:t>12</a:t>
+              <a:t>11</a:t>
             </a:r>
           </a:p>
         </p:txBody>
@@ -8800,7 +9147,7 @@
                 </a:solidFill>
                 <a:latin typeface="Arial"/>
               </a:rPr>
-              <a:t>5 / 15   ·   Hyewon Kim</a:t>
+              <a:t>5 / 16   ·   Hyewon Kim</a:t>
             </a:r>
           </a:p>
         </p:txBody>
@@ -8821,8 +9168,8 @@
         </p:blipFill>
         <p:spPr>
           <a:xfrm>
-            <a:off x="640000" y="1289140"/>
-            <a:ext cx="10912000" cy="4371720"/>
+            <a:off x="640000" y="1331734"/>
+            <a:ext cx="10912000" cy="4286532"/>
           </a:xfrm>
           <a:prstGeom prst="rect">
             <a:avLst/>
@@ -8863,7 +9210,7 @@
                 </a:solidFill>
                 <a:latin typeface="Arial"/>
               </a:rPr>
-              <a:t>Substitution use cases with «include» / «extend» (overview of all 13 in the report)</a:t>
+              <a:t>Substitution use cases with «include» / «extend» (overview of all 12 in the report)</a:t>
             </a:r>
           </a:p>
         </p:txBody>
@@ -9003,7 +9350,7 @@
                 </a:solidFill>
                 <a:latin typeface="Arial"/>
               </a:rPr>
-              <a:t>6 / 15   ·   Hyewon Kim</a:t>
+              <a:t>6 / 16   ·   Hyewon Kim</a:t>
             </a:r>
           </a:p>
         </p:txBody>
@@ -9340,7 +9687,7 @@
             <a:avLst/>
           </a:prstGeom>
           <a:solidFill>
-            <a:srgbClr val="E9A23B"/>
+            <a:srgbClr val="2B5BD7"/>
           </a:solidFill>
           <a:ln>
             <a:noFill/>
@@ -9403,7 +9750,7 @@
                 </a:solidFill>
                 <a:latin typeface="Arial"/>
               </a:rPr>
-              <a:t>Architecture: a client-only web app</a:t>
+              <a:t>A requirement we changed</a:t>
             </a:r>
           </a:p>
         </p:txBody>
@@ -9442,35 +9789,55 @@
                 </a:solidFill>
                 <a:latin typeface="Arial"/>
               </a:rPr>
-              <a:t>7 / 15   ·   Hyoungdo Kim</a:t>
-            </a:r>
-          </a:p>
-        </p:txBody>
-      </p:sp>
-      <p:pic>
-        <p:nvPicPr>
-          <p:cNvPr id="5" name="Picture 4" descr="component.png"/>
-          <p:cNvPicPr>
-            <a:picLocks noChangeAspect="1"/>
-          </p:cNvPicPr>
-          <p:nvPr/>
-        </p:nvPicPr>
-        <p:blipFill>
-          <a:blip r:embed="rId2"/>
-          <a:stretch>
-            <a:fillRect/>
-          </a:stretch>
-        </p:blipFill>
-        <p:spPr>
-          <a:xfrm>
-            <a:off x="1104296" y="1250000"/>
-            <a:ext cx="9983408" cy="4450000"/>
-          </a:xfrm>
-          <a:prstGeom prst="rect">
-            <a:avLst/>
-          </a:prstGeom>
-        </p:spPr>
-      </p:pic>
+              <a:t>7 / 16   ·   Hyewon Kim</a:t>
+            </a:r>
+          </a:p>
+        </p:txBody>
+      </p:sp>
+      <p:sp>
+        <p:nvSpPr>
+          <p:cNvPr id="5" name="Rectangle 4"/>
+          <p:cNvSpPr/>
+          <p:nvPr/>
+        </p:nvSpPr>
+        <p:spPr>
+          <a:xfrm>
+            <a:off x="640000" y="1450000"/>
+            <a:ext cx="3504000" cy="3800000"/>
+          </a:xfrm>
+          <a:prstGeom prst="rect">
+            <a:avLst/>
+          </a:prstGeom>
+          <a:solidFill>
+            <a:srgbClr val="F4F6F9"/>
+          </a:solidFill>
+          <a:ln>
+            <a:noFill/>
+          </a:ln>
+          <a:effectLst/>
+        </p:spPr>
+        <p:style>
+          <a:lnRef idx="1">
+            <a:schemeClr val="accent1"/>
+          </a:lnRef>
+          <a:fillRef idx="3">
+            <a:schemeClr val="accent1"/>
+          </a:fillRef>
+          <a:effectRef idx="2">
+            <a:schemeClr val="accent1"/>
+          </a:effectRef>
+          <a:fontRef idx="minor">
+            <a:schemeClr val="lt1"/>
+          </a:fontRef>
+        </p:style>
+        <p:txBody>
+          <a:bodyPr rtlCol="0" anchor="ctr"/>
+          <a:lstStyle/>
+          <a:p>
+            <a:pPr algn="ctr"/>
+          </a:p>
+        </p:txBody>
+      </p:sp>
       <p:sp>
         <p:nvSpPr>
           <p:cNvPr id="6" name="TextBox 5"/>
@@ -9479,8 +9846,8 @@
         </p:nvSpPr>
         <p:spPr>
           <a:xfrm>
-            <a:off x="640000" y="5750000"/>
-            <a:ext cx="10912000" cy="400000"/>
+            <a:off x="840000" y="1600000"/>
+            <a:ext cx="3104000" cy="500000"/>
           </a:xfrm>
           <a:prstGeom prst="rect">
             <a:avLst/>
@@ -9495,17 +9862,417 @@
           <a:p>
             <a:pPr algn="l">
               <a:spcAft>
-                <a:spcPts val="650"/>
+                <a:spcPts val="800"/>
               </a:spcAft>
             </a:pPr>
             <a:r>
-              <a:rPr sz="1300" b="0">
-                <a:solidFill>
-                  <a:srgbClr val="4A5163"/>
+              <a:rPr sz="1600" b="1">
+                <a:solidFill>
+                  <a:srgbClr val="2B5BD7"/>
+                </a:solidFill>
+                <a:latin typeface="Courier New"/>
+              </a:rPr>
+              <a:t>Found</a:t>
+            </a:r>
+          </a:p>
+        </p:txBody>
+      </p:sp>
+      <p:sp>
+        <p:nvSpPr>
+          <p:cNvPr id="7" name="TextBox 6"/>
+          <p:cNvSpPr txBox="1"/>
+          <p:nvPr/>
+        </p:nvSpPr>
+        <p:spPr>
+          <a:xfrm>
+            <a:off x="840000" y="2100000"/>
+            <a:ext cx="3104000" cy="700000"/>
+          </a:xfrm>
+          <a:prstGeom prst="rect">
+            <a:avLst/>
+          </a:prstGeom>
+          <a:noFill/>
+        </p:spPr>
+        <p:txBody>
+          <a:bodyPr wrap="square">
+            <a:spAutoFit/>
+          </a:bodyPr>
+          <a:lstStyle/>
+          <a:p>
+            <a:pPr algn="l">
+              <a:spcAft>
+                <a:spcPts val="1100"/>
+              </a:spcAft>
+            </a:pPr>
+            <a:r>
+              <a:rPr sz="2200" b="1">
+                <a:solidFill>
+                  <a:srgbClr val="1C2230"/>
                 </a:solidFill>
                 <a:latin typeface="Arial"/>
               </a:rPr>
-              <a:t>Presentation → application services → pure rules → SQLite (sql.js, WebAssembly) → localStorage</a:t>
+              <a:t>A dead end</a:t>
+            </a:r>
+          </a:p>
+        </p:txBody>
+      </p:sp>
+      <p:sp>
+        <p:nvSpPr>
+          <p:cNvPr id="8" name="TextBox 7"/>
+          <p:cNvSpPr txBox="1"/>
+          <p:nvPr/>
+        </p:nvSpPr>
+        <p:spPr>
+          <a:xfrm>
+            <a:off x="840000" y="2950000"/>
+            <a:ext cx="3104000" cy="2200000"/>
+          </a:xfrm>
+          <a:prstGeom prst="rect">
+            <a:avLst/>
+          </a:prstGeom>
+          <a:noFill/>
+        </p:spPr>
+        <p:txBody>
+          <a:bodyPr wrap="square">
+            <a:spAutoFit/>
+          </a:bodyPr>
+          <a:lstStyle/>
+          <a:p>
+            <a:pPr algn="l">
+              <a:spcAft>
+                <a:spcPts val="800"/>
+              </a:spcAft>
+            </a:pPr>
+            <a:r>
+              <a:rPr sz="1600" b="0">
+                <a:solidFill>
+                  <a:srgbClr val="4A5163"/>
+                </a:solidFill>
+                <a:latin typeface="Arial"/>
+              </a:rPr>
+              <a:t>When nobody's availability matched, the owner was only told 'no candidate' and could do nothing.</a:t>
+            </a:r>
+          </a:p>
+        </p:txBody>
+      </p:sp>
+      <p:sp>
+        <p:nvSpPr>
+          <p:cNvPr id="9" name="Rectangle 8"/>
+          <p:cNvSpPr/>
+          <p:nvPr/>
+        </p:nvSpPr>
+        <p:spPr>
+          <a:xfrm>
+            <a:off x="4344000" y="1450000"/>
+            <a:ext cx="3504000" cy="3800000"/>
+          </a:xfrm>
+          <a:prstGeom prst="rect">
+            <a:avLst/>
+          </a:prstGeom>
+          <a:solidFill>
+            <a:srgbClr val="F4F6F9"/>
+          </a:solidFill>
+          <a:ln>
+            <a:noFill/>
+          </a:ln>
+          <a:effectLst/>
+        </p:spPr>
+        <p:style>
+          <a:lnRef idx="1">
+            <a:schemeClr val="accent1"/>
+          </a:lnRef>
+          <a:fillRef idx="3">
+            <a:schemeClr val="accent1"/>
+          </a:fillRef>
+          <a:effectRef idx="2">
+            <a:schemeClr val="accent1"/>
+          </a:effectRef>
+          <a:fontRef idx="minor">
+            <a:schemeClr val="lt1"/>
+          </a:fontRef>
+        </p:style>
+        <p:txBody>
+          <a:bodyPr rtlCol="0" anchor="ctr"/>
+          <a:lstStyle/>
+          <a:p>
+            <a:pPr algn="ctr"/>
+          </a:p>
+        </p:txBody>
+      </p:sp>
+      <p:sp>
+        <p:nvSpPr>
+          <p:cNvPr id="10" name="TextBox 9"/>
+          <p:cNvSpPr txBox="1"/>
+          <p:nvPr/>
+        </p:nvSpPr>
+        <p:spPr>
+          <a:xfrm>
+            <a:off x="4544000" y="1600000"/>
+            <a:ext cx="3104000" cy="500000"/>
+          </a:xfrm>
+          <a:prstGeom prst="rect">
+            <a:avLst/>
+          </a:prstGeom>
+          <a:noFill/>
+        </p:spPr>
+        <p:txBody>
+          <a:bodyPr wrap="square">
+            <a:spAutoFit/>
+          </a:bodyPr>
+          <a:lstStyle/>
+          <a:p>
+            <a:pPr algn="l">
+              <a:spcAft>
+                <a:spcPts val="800"/>
+              </a:spcAft>
+            </a:pPr>
+            <a:r>
+              <a:rPr sz="1600" b="1">
+                <a:solidFill>
+                  <a:srgbClr val="2B5BD7"/>
+                </a:solidFill>
+                <a:latin typeface="Courier New"/>
+              </a:rPr>
+              <a:t>Decided</a:t>
+            </a:r>
+          </a:p>
+        </p:txBody>
+      </p:sp>
+      <p:sp>
+        <p:nvSpPr>
+          <p:cNvPr id="11" name="TextBox 10"/>
+          <p:cNvSpPr txBox="1"/>
+          <p:nvPr/>
+        </p:nvSpPr>
+        <p:spPr>
+          <a:xfrm>
+            <a:off x="4544000" y="2100000"/>
+            <a:ext cx="3104000" cy="700000"/>
+          </a:xfrm>
+          <a:prstGeom prst="rect">
+            <a:avLst/>
+          </a:prstGeom>
+          <a:noFill/>
+        </p:spPr>
+        <p:txBody>
+          <a:bodyPr wrap="square">
+            <a:spAutoFit/>
+          </a:bodyPr>
+          <a:lstStyle/>
+          <a:p>
+            <a:pPr algn="l">
+              <a:spcAft>
+                <a:spcPts val="1100"/>
+              </a:spcAft>
+            </a:pPr>
+            <a:r>
+              <a:rPr sz="2200" b="1">
+                <a:solidFill>
+                  <a:srgbClr val="1C2230"/>
+                </a:solidFill>
+                <a:latin typeface="Arial"/>
+              </a:rPr>
+              <a:t>Ask everyone, allow 'can't'</a:t>
+            </a:r>
+          </a:p>
+        </p:txBody>
+      </p:sp>
+      <p:sp>
+        <p:nvSpPr>
+          <p:cNvPr id="12" name="TextBox 11"/>
+          <p:cNvSpPr txBox="1"/>
+          <p:nvPr/>
+        </p:nvSpPr>
+        <p:spPr>
+          <a:xfrm>
+            <a:off x="4544000" y="2950000"/>
+            <a:ext cx="3104000" cy="2200000"/>
+          </a:xfrm>
+          <a:prstGeom prst="rect">
+            <a:avLst/>
+          </a:prstGeom>
+          <a:noFill/>
+        </p:spPr>
+        <p:txBody>
+          <a:bodyPr wrap="square">
+            <a:spAutoFit/>
+          </a:bodyPr>
+          <a:lstStyle/>
+          <a:p>
+            <a:pPr algn="l">
+              <a:spcAft>
+                <a:spcPts val="800"/>
+              </a:spcAft>
+            </a:pPr>
+            <a:r>
+              <a:rPr sz="1600" b="0">
+                <a:solidFill>
+                  <a:srgbClr val="4A5163"/>
+                </a:solidFill>
+                <a:latin typeface="Arial"/>
+              </a:rPr>
+              <a:t>Availability is no longer collected. Every co-worker not already working is asked; the first to accept takes it.</a:t>
+            </a:r>
+          </a:p>
+        </p:txBody>
+      </p:sp>
+      <p:sp>
+        <p:nvSpPr>
+          <p:cNvPr id="13" name="Rectangle 12"/>
+          <p:cNvSpPr/>
+          <p:nvPr/>
+        </p:nvSpPr>
+        <p:spPr>
+          <a:xfrm>
+            <a:off x="8048000" y="1450000"/>
+            <a:ext cx="3504000" cy="3800000"/>
+          </a:xfrm>
+          <a:prstGeom prst="rect">
+            <a:avLst/>
+          </a:prstGeom>
+          <a:solidFill>
+            <a:srgbClr val="F4F6F9"/>
+          </a:solidFill>
+          <a:ln>
+            <a:noFill/>
+          </a:ln>
+          <a:effectLst/>
+        </p:spPr>
+        <p:style>
+          <a:lnRef idx="1">
+            <a:schemeClr val="accent1"/>
+          </a:lnRef>
+          <a:fillRef idx="3">
+            <a:schemeClr val="accent1"/>
+          </a:fillRef>
+          <a:effectRef idx="2">
+            <a:schemeClr val="accent1"/>
+          </a:effectRef>
+          <a:fontRef idx="minor">
+            <a:schemeClr val="lt1"/>
+          </a:fontRef>
+        </p:style>
+        <p:txBody>
+          <a:bodyPr rtlCol="0" anchor="ctr"/>
+          <a:lstStyle/>
+          <a:p>
+            <a:pPr algn="ctr"/>
+          </a:p>
+        </p:txBody>
+      </p:sp>
+      <p:sp>
+        <p:nvSpPr>
+          <p:cNvPr id="14" name="TextBox 13"/>
+          <p:cNvSpPr txBox="1"/>
+          <p:nvPr/>
+        </p:nvSpPr>
+        <p:spPr>
+          <a:xfrm>
+            <a:off x="8248000" y="1600000"/>
+            <a:ext cx="3104000" cy="500000"/>
+          </a:xfrm>
+          <a:prstGeom prst="rect">
+            <a:avLst/>
+          </a:prstGeom>
+          <a:noFill/>
+        </p:spPr>
+        <p:txBody>
+          <a:bodyPr wrap="square">
+            <a:spAutoFit/>
+          </a:bodyPr>
+          <a:lstStyle/>
+          <a:p>
+            <a:pPr algn="l">
+              <a:spcAft>
+                <a:spcPts val="800"/>
+              </a:spcAft>
+            </a:pPr>
+            <a:r>
+              <a:rPr sz="1600" b="1">
+                <a:solidFill>
+                  <a:srgbClr val="2B5BD7"/>
+                </a:solidFill>
+                <a:latin typeface="Courier New"/>
+              </a:rPr>
+              <a:t>Result</a:t>
+            </a:r>
+          </a:p>
+        </p:txBody>
+      </p:sp>
+      <p:sp>
+        <p:nvSpPr>
+          <p:cNvPr id="15" name="TextBox 14"/>
+          <p:cNvSpPr txBox="1"/>
+          <p:nvPr/>
+        </p:nvSpPr>
+        <p:spPr>
+          <a:xfrm>
+            <a:off x="8248000" y="2100000"/>
+            <a:ext cx="3104000" cy="700000"/>
+          </a:xfrm>
+          <a:prstGeom prst="rect">
+            <a:avLst/>
+          </a:prstGeom>
+          <a:noFill/>
+        </p:spPr>
+        <p:txBody>
+          <a:bodyPr wrap="square">
+            <a:spAutoFit/>
+          </a:bodyPr>
+          <a:lstStyle/>
+          <a:p>
+            <a:pPr algn="l">
+              <a:spcAft>
+                <a:spcPts val="1100"/>
+              </a:spcAft>
+            </a:pPr>
+            <a:r>
+              <a:rPr sz="2200" b="1">
+                <a:solidFill>
+                  <a:srgbClr val="1C2230"/>
+                </a:solidFill>
+                <a:latin typeface="Arial"/>
+              </a:rPr>
+              <a:t>A clear ending</a:t>
+            </a:r>
+          </a:p>
+        </p:txBody>
+      </p:sp>
+      <p:sp>
+        <p:nvSpPr>
+          <p:cNvPr id="16" name="TextBox 15"/>
+          <p:cNvSpPr txBox="1"/>
+          <p:nvPr/>
+        </p:nvSpPr>
+        <p:spPr>
+          <a:xfrm>
+            <a:off x="8248000" y="2950000"/>
+            <a:ext cx="3104000" cy="2200000"/>
+          </a:xfrm>
+          <a:prstGeom prst="rect">
+            <a:avLst/>
+          </a:prstGeom>
+          <a:noFill/>
+        </p:spPr>
+        <p:txBody>
+          <a:bodyPr wrap="square">
+            <a:spAutoFit/>
+          </a:bodyPr>
+          <a:lstStyle/>
+          <a:p>
+            <a:pPr algn="l">
+              <a:spcAft>
+                <a:spcPts val="800"/>
+              </a:spcAft>
+            </a:pPr>
+            <a:r>
+              <a:rPr sz="1600" b="0">
+                <a:solidFill>
+                  <a:srgbClr val="4A5163"/>
+                </a:solidFill>
+                <a:latin typeface="Arial"/>
+              </a:rPr>
+              <a:t>If everyone answers 'can't', the requester is told to call the owner and the owner gets one card to acknowledge.</a:t>
             </a:r>
           </a:p>
         </p:txBody>
@@ -9606,7 +10373,7 @@
                 </a:solidFill>
                 <a:latin typeface="Arial"/>
               </a:rPr>
-              <a:t>First acceptance wins</a:t>
+              <a:t>Architecture: a client-only web app</a:t>
             </a:r>
           </a:p>
         </p:txBody>
@@ -9645,14 +10412,14 @@
                 </a:solidFill>
                 <a:latin typeface="Arial"/>
               </a:rPr>
-              <a:t>8 / 15   ·   Hyoungdo Kim</a:t>
+              <a:t>8 / 16   ·   Hyoungdo Kim</a:t>
             </a:r>
           </a:p>
         </p:txBody>
       </p:sp>
       <p:pic>
         <p:nvPicPr>
-          <p:cNvPr id="5" name="Picture 4" descr="seq-2-accept.png"/>
+          <p:cNvPr id="5" name="Picture 4" descr="component.png"/>
           <p:cNvPicPr>
             <a:picLocks noChangeAspect="1"/>
           </p:cNvPicPr>
@@ -9666,8 +10433,8 @@
         </p:blipFill>
         <p:spPr>
           <a:xfrm>
-            <a:off x="3862531" y="1250000"/>
-            <a:ext cx="4466938" cy="4450000"/>
+            <a:off x="1106986" y="1250000"/>
+            <a:ext cx="9978028" cy="4450000"/>
           </a:xfrm>
           <a:prstGeom prst="rect">
             <a:avLst/>
@@ -9708,7 +10475,7 @@
                 </a:solidFill>
                 <a:latin typeface="Arial"/>
               </a:rPr>
-              <a:t>Sequence SD-2: the second acceptance re-checks the state inside its transaction and is refused</a:t>
+              <a:t>Presentation → application services → pure rules → SQLite (sql.js, WebAssembly) → localStorage</a:t>
             </a:r>
           </a:p>
         </p:txBody>
@@ -9809,7 +10576,7 @@
                 </a:solidFill>
                 <a:latin typeface="Arial"/>
               </a:rPr>
-              <a:t>Life of a substitute request</a:t>
+              <a:t>First acceptance wins</a:t>
             </a:r>
           </a:p>
         </p:txBody>
@@ -9848,14 +10615,14 @@
                 </a:solidFill>
                 <a:latin typeface="Arial"/>
               </a:rPr>
-              <a:t>9 / 15   ·   Hyoungdo Kim</a:t>
+              <a:t>9 / 16   ·   Hyoungdo Kim</a:t>
             </a:r>
           </a:p>
         </p:txBody>
       </p:sp>
       <p:pic>
         <p:nvPicPr>
-          <p:cNvPr id="5" name="Picture 4" descr="state-subrequest.png"/>
+          <p:cNvPr id="5" name="Picture 4" descr="seq-2-accept.png"/>
           <p:cNvPicPr>
             <a:picLocks noChangeAspect="1"/>
           </p:cNvPicPr>
@@ -9869,8 +10636,8 @@
         </p:blipFill>
         <p:spPr>
           <a:xfrm>
-            <a:off x="640000" y="1502363"/>
-            <a:ext cx="10912000" cy="3945274"/>
+            <a:off x="4584910" y="1250000"/>
+            <a:ext cx="3022179" cy="4450000"/>
           </a:xfrm>
           <a:prstGeom prst="rect">
             <a:avLst/>
@@ -9911,7 +10678,7 @@
                 </a:solidFill>
                 <a:latin typeface="Arial"/>
               </a:rPr>
-              <a:t>State diagram: REQUESTED → ACCEPTED → APPROVED / REJECTED, with EXPIRED and CANCELLED</a:t>
+              <a:t>Sequence SD-2: the second acceptance re-checks the state inside its transaction and is refused</a:t>
             </a:r>
           </a:p>
         </p:txBody>

</xml_diff>

<commit_message>
Final build: reproduction run 3 (84/84), report 119 pages, interim screenshots frozen, NFR-03 re-measured, deck 16 slides
Co-Authored-By: Claude Opus 5.5 <noreply@anthropic.com>
</commit_message>
<xml_diff>
--- a/presentation/ShiftSwap-Team7.pptx
+++ b/presentation/ShiftSwap-Team7.pptx
@@ -5808,8 +5808,8 @@
         </p:blipFill>
         <p:spPr>
           <a:xfrm>
-            <a:off x="5424367" y="1250000"/>
-            <a:ext cx="1343266" cy="4450000"/>
+            <a:off x="5487337" y="1250000"/>
+            <a:ext cx="1217325" cy="4450000"/>
           </a:xfrm>
           <a:prstGeom prst="rect">
             <a:avLst/>
@@ -6669,7 +6669,7 @@
                 </a:solidFill>
                 <a:latin typeface="Arial"/>
               </a:rPr>
-              <a:t>77/77</a:t>
+              <a:t>84/84</a:t>
             </a:r>
           </a:p>
         </p:txBody>
@@ -6747,7 +6747,7 @@
                 </a:solidFill>
                 <a:latin typeface="Arial"/>
               </a:rPr>
-              <a:t>prompt v5 re-run in an empty folder</a:t>
+              <a:t>final prompt v6 re-run in an empty folder</a:t>
             </a:r>
           </a:p>
         </p:txBody>
@@ -7229,7 +7229,7 @@
                           </a:solidFill>
                           <a:latin typeface="Arial"/>
                         </a:rPr>
-                        <a:t>12 use cases · 11 tables · 5,426 lines of application code · 1,051 lines of tests</a:t>
+                        <a:t>12 use cases · 11 tables · 5,465 lines of application code · 1,051 lines of tests</a:t>
                       </a:r>
                     </a:p>
                   </a:txBody>
@@ -10433,8 +10433,8 @@
         </p:blipFill>
         <p:spPr>
           <a:xfrm>
-            <a:off x="1106986" y="1250000"/>
-            <a:ext cx="9978028" cy="4450000"/>
+            <a:off x="1037453" y="1250000"/>
+            <a:ext cx="10117094" cy="4450000"/>
           </a:xfrm>
           <a:prstGeom prst="rect">
             <a:avLst/>

</xml_diff>

<commit_message>
Iteration 7: contract work history and automatic monthly payroll draft; team e-mails; reproduction run 4 (89/89); report 130 pages
Co-Authored-By: Claude Opus 5.5 <noreply@anthropic.com>
</commit_message>
<xml_diff>
--- a/presentation/ShiftSwap-Team7.pptx
+++ b/presentation/ShiftSwap-Team7.pptx
@@ -672,7 +672,7 @@
           </a:p>
           <a:p>
             <a:r>
-              <a:t>We did not write code by hand. We wrote one prompt that treats the specification as a contract, and let the AI coding assistant build the system. Every ambiguity the build found went into a prompt log and back into the specification. Six versions were needed. The last one came from re-running the prompt in an empty folder: the rebuilt system worked, but its function signatures differed from ours, so version five supplies our test files as the contract. I hand over to Minkyung.</a:t>
+              <a:t>We did not write code by hand. We wrote one prompt that treats the specification as a contract, and let the AI coding assistant build the system. Every ambiguity the build found went into a prompt log and back into the specification. Seven versions were needed. The last one came from re-running the prompt in an empty folder: the rebuilt system worked, but its function signatures differed from ours, so version five supplies our test files as the contract. I hand over to Minkyung.</a:t>
             </a:r>
           </a:p>
         </p:txBody>
@@ -897,7 +897,7 @@
           </a:p>
           <a:p>
             <a:r>
-              <a:t>At month end the owner generates payroll. Doyun's hourly wage is below the 2026 minimum wage, so the row is flagged and the month cannot be confirmed until the owner acknowledges the warning.</a:t>
+              <a:t>On the first day of each month the system prepares last month's payroll as a draft and tells the owner. March to August are already confirmed from the employees' contracts. Doyun's hourly wage is below the 2026 minimum wage, so the row is flagged and the month cannot be confirmed until the owner acknowledges the warning.</a:t>
             </a:r>
           </a:p>
         </p:txBody>
@@ -972,7 +972,7 @@
           </a:p>
           <a:p>
             <a:r>
-              <a:t>All 84 automated tests pass. They include boundary values such as fourteen point nine nine versus fifteen hours, the forty-hour cap, both attendance policies, and the concurrent acceptance. The traceability matrix in the report links every functional requirement to its use case, screen, function and tests.</a:t>
+              <a:t>All 89 automated tests pass. They include boundary values such as fourteen point nine nine versus fifteen hours, the forty-hour cap, both attendance policies, and the concurrent acceptance. The traceability matrix in the report links every functional requirement to its use case, screen, function and tests.</a:t>
             </a:r>
           </a:p>
         </p:txBody>
@@ -5173,7 +5173,7 @@
                 </a:solidFill>
                 <a:latin typeface="Arial"/>
               </a:rPr>
-              <a:t>Vibe coding: six prompt versions</a:t>
+              <a:t>Vibe coding: seven prompt versions</a:t>
             </a:r>
           </a:p>
         </p:txBody>
@@ -5227,7 +5227,7 @@
         </p:nvGraphicFramePr>
         <p:xfrm>
           <a:off x="640000" y="1450000"/>
-          <a:ext cx="10912000" cy="4200000"/>
+          <a:ext cx="10912000" cy="4900000"/>
         </p:xfrm>
         <a:graphic>
           <a:graphicData uri="http://schemas.openxmlformats.org/drawingml/2006/table">
@@ -5648,6 +5648,74 @@
                   </a:tcPr>
                 </a:tc>
               </a:tr>
+              <a:tr h="700000">
+                <a:tc>
+                  <a:txBody>
+                    <a:bodyPr/>
+                    <a:lstStyle/>
+                    <a:p>
+                      <a:r>
+                        <a:rPr sz="1400" b="1">
+                          <a:solidFill>
+                            <a:srgbClr val="1C2230"/>
+                          </a:solidFill>
+                          <a:latin typeface="Courier New"/>
+                        </a:rPr>
+                        <a:t>v7</a:t>
+                      </a:r>
+                    </a:p>
+                  </a:txBody>
+                  <a:tcPr>
+                    <a:solidFill>
+                      <a:srgbClr val="F4F6F9"/>
+                    </a:solidFill>
+                  </a:tcPr>
+                </a:tc>
+                <a:tc>
+                  <a:txBody>
+                    <a:bodyPr/>
+                    <a:lstStyle/>
+                    <a:p>
+                      <a:r>
+                        <a:rPr sz="1500" b="0">
+                          <a:solidFill>
+                            <a:srgbClr val="1C2230"/>
+                          </a:solidFill>
+                          <a:latin typeface="Arial"/>
+                        </a:rPr>
+                        <a:t>Owner request: history and automatic payroll</a:t>
+                      </a:r>
+                    </a:p>
+                  </a:txBody>
+                  <a:tcPr>
+                    <a:solidFill>
+                      <a:srgbClr val="FFFFFF"/>
+                    </a:solidFill>
+                  </a:tcPr>
+                </a:tc>
+                <a:tc>
+                  <a:txBody>
+                    <a:bodyPr/>
+                    <a:lstStyle/>
+                    <a:p>
+                      <a:r>
+                        <a:rPr sz="1500" b="0">
+                          <a:solidFill>
+                            <a:srgbClr val="1C2230"/>
+                          </a:solidFill>
+                          <a:latin typeface="Arial"/>
+                        </a:rPr>
+                        <a:t>Contract history seeded; last month's draft on the 1st</a:t>
+                      </a:r>
+                    </a:p>
+                  </a:txBody>
+                  <a:tcPr>
+                    <a:solidFill>
+                      <a:srgbClr val="FFFFFF"/>
+                    </a:solidFill>
+                  </a:tcPr>
+                </a:tc>
+              </a:tr>
             </a:tbl>
           </a:graphicData>
         </a:graphic>
@@ -6154,7 +6222,7 @@
                 </a:solidFill>
                 <a:latin typeface="Arial"/>
               </a:rPr>
-              <a:t>Month end: payroll with legal checks</a:t>
+              <a:t>Month end: payroll prepares itself</a:t>
             </a:r>
           </a:p>
         </p:txBody>
@@ -6435,7 +6503,7 @@
                 </a:solidFill>
                 <a:latin typeface="Arial"/>
               </a:rPr>
-              <a:t>84/84</a:t>
+              <a:t>89/89</a:t>
             </a:r>
           </a:p>
         </p:txBody>
@@ -6552,7 +6620,7 @@
                 </a:solidFill>
                 <a:latin typeface="Arial"/>
               </a:rPr>
-              <a:t>13/13</a:t>
+              <a:t>14/14</a:t>
             </a:r>
           </a:p>
         </p:txBody>
@@ -6669,7 +6737,7 @@
                 </a:solidFill>
                 <a:latin typeface="Arial"/>
               </a:rPr>
-              <a:t>84/84</a:t>
+              <a:t>89/89</a:t>
             </a:r>
           </a:p>
         </p:txBody>
@@ -6747,7 +6815,7 @@
                 </a:solidFill>
                 <a:latin typeface="Arial"/>
               </a:rPr>
-              <a:t>final prompt v6 re-run in an empty folder</a:t>
+              <a:t>final prompt v7 re-run in an empty folder</a:t>
             </a:r>
           </a:p>
         </p:txBody>
@@ -7229,7 +7297,7 @@
                           </a:solidFill>
                           <a:latin typeface="Arial"/>
                         </a:rPr>
-                        <a:t>12 use cases · 11 tables · 5,465 lines of application code · 1,051 lines of tests</a:t>
+                        <a:t>13 use cases · 11 tables · 5,648 lines of application code · 1,211 lines of tests</a:t>
                       </a:r>
                     </a:p>
                   </a:txBody>
@@ -8461,7 +8529,7 @@
                 </a:solidFill>
                 <a:latin typeface="Arial"/>
               </a:rPr>
-              <a:t>12</a:t>
+              <a:t>13</a:t>
             </a:r>
           </a:p>
         </p:txBody>
@@ -8539,7 +8607,7 @@
                 </a:solidFill>
                 <a:latin typeface="Arial"/>
               </a:rPr>
-              <a:t>UC-02 retired in iteration 6</a:t>
+              <a:t>UC-14 added, UC-02 retired</a:t>
             </a:r>
           </a:p>
         </p:txBody>
@@ -8578,7 +8646,7 @@
                 </a:solidFill>
                 <a:latin typeface="Arial"/>
               </a:rPr>
-              <a:t>21</a:t>
+              <a:t>22</a:t>
             </a:r>
           </a:p>
         </p:txBody>
@@ -8656,7 +8724,7 @@
                 </a:solidFill>
                 <a:latin typeface="Arial"/>
               </a:rPr>
-              <a:t>FR-01 … FR-22, FR-03 retired</a:t>
+              <a:t>FR-01 … FR-23, FR-03 retired</a:t>
             </a:r>
           </a:p>
         </p:txBody>
@@ -8812,7 +8880,7 @@
                 </a:solidFill>
                 <a:latin typeface="Arial"/>
               </a:rPr>
-              <a:t>13</a:t>
+              <a:t>14</a:t>
             </a:r>
           </a:p>
         </p:txBody>
@@ -8890,7 +8958,7 @@
                 </a:solidFill>
                 <a:latin typeface="Arial"/>
               </a:rPr>
-              <a:t>BR-01 … BR-13, each tested</a:t>
+              <a:t>BR-01 … BR-14, each tested</a:t>
             </a:r>
           </a:p>
         </p:txBody>

</xml_diff>

<commit_message>
Deck for iteration 8: shared database, BR-15, reproduction 113/113
Co-Authored-By: Claude <noreply@anthropic.com>
</commit_message>
<xml_diff>
--- a/presentation/ShiftSwap-Team7.pptx
+++ b/presentation/ShiftSwap-Team7.pptx
@@ -672,7 +672,7 @@
           </a:p>
           <a:p>
             <a:r>
-              <a:t>We did not write code by hand. We wrote one prompt that treats the specification as a contract, and let the AI coding assistant build the system. Every ambiguity the build found went into a prompt log and back into the specification. Seven versions were needed. The last one came from re-running the prompt in an empty folder: the rebuilt system worked, but its function signatures differed from ours, so version five supplies our test files as the contract. I hand over to Minkyung.</a:t>
+              <a:t>We did not write code by hand. We wrote one prompt that treats the specification as a contract, and let the AI coding assistant build the system. Every ambiguity the build found went into a prompt log and back into the specification. Eight versions were needed; the last one followed the revised proposal: a shared database, so that everyone who opens the demo sees the same data, and the part-time overtime rule. The last one came from re-running the prompt in an empty folder: the rebuilt system worked, but its function signatures differed from ours, so version five supplies our test files as the contract. I hand over to Minkyung.</a:t>
             </a:r>
           </a:p>
         </p:txBody>
@@ -972,7 +972,7 @@
           </a:p>
           <a:p>
             <a:r>
-              <a:t>All 89 automated tests pass. They include boundary values such as fourteen point nine nine versus fifteen hours, the forty-hour cap, both attendance policies, and the concurrent acceptance. The traceability matrix in the report links every functional requirement to its use case, screen, function and tests.</a:t>
+              <a:t>All 125 automated tests pass. They include boundary values such as fourteen point nine nine versus fifteen hours, the forty-hour cap, both attendance policies, the part-time limit, and the concurrent acceptance — also between two browsers on the shared database. The traceability matrix in the report links every functional requirement to its use case, screen, function and tests.</a:t>
             </a:r>
           </a:p>
         </p:txBody>
@@ -1047,7 +1047,7 @@
           </a:p>
           <a:p>
             <a:r>
-              <a:t>To sum up: the owner no longer contacts workers one by one, candidates answer in two clicks, and every swap updates both workers' hours and pay eligibility. The limits are those of a client-only demo: no real login and data kept in one browser. The next step would be a server and a field test in the café. Thank you. We are happy to take questions.</a:t>
+              <a:t>To sum up: the owner no longer contacts workers one by one, candidates answer in two clicks, and every swap updates both workers' hours and pay eligibility. Everyone who opens the demo now works on the same shared data. The main limit is that there is no real login: anyone can act as any demo account. The next steps would be login with ownership of each row and a field test in the café. Thank you. We are happy to take questions.</a:t>
             </a:r>
           </a:p>
         </p:txBody>
@@ -1272,7 +1272,7 @@
           </a:p>
           <a:p>
             <a:r>
-              <a:t>From interviews and the legal sources we wrote twenty-one functional requirements and thirteen non-functional requirements, classified as product, organisational and external requirements as in Chapter 8. The core logic is captured in twelve business rules, and the data in twelve tables. This is well above the course minimum of five use cases and four tables.</a:t>
+              <a:t>From interviews and the legal sources we wrote twenty-three functional requirements and sixteen non-functional requirements, classified as product, organisational and external requirements as in Chapter 8. The core logic is captured in fifteen business rules, and the data in eleven tables, which exist both in the browser database and in the shared database. This is well above the course minimum of five use cases and four tables.</a:t>
             </a:r>
           </a:p>
         </p:txBody>
@@ -1422,7 +1422,7 @@
           </a:p>
           <a:p>
             <a:r>
-              <a:t>The legal rules became business rules that can be tested. For example, the holiday allowance exists only when the contract has at least fifteen hours a week and the worker was not absent; the hours are capped at forty. Because handing a shift over is legally unclear, the attendance effect of a swap is a setting the owner chooses.</a:t>
+              <a:t>The legal rules became business rules that can be tested. For example, the holiday allowance exists only when the contract has at least fifteen hours a week and the worker was not absent; the hours are capped at forty. In workplaces with five or more regular employees, a part-time worker's hours beyond the contract earn the premium, and the approval card warns when a swap would exceed the legal limit of twelve such hours a week. Because handing a shift over is legally unclear, the attendance effect of a swap is a setting the owner chooses.</a:t>
             </a:r>
           </a:p>
         </p:txBody>
@@ -1572,7 +1572,7 @@
           </a:p>
           <a:p>
             <a:r>
-              <a:t>The system runs entirely in the browser, so it can be hosted on GitHub Pages without a server. The user interface calls application services, one per use-case step. The services call pure rule functions that contain no database code, which is why every rule can be unit-tested. The data lives in a real SQLite database compiled to WebAssembly and is saved in the browser.</a:t>
+              <a:t>The application is a static web app on GitHub Pages; it has no application server of its own. The user interface calls application services, one per use-case step. The services call pure rule functions that contain no database code, which is why every rule can be unit-tested. The services work on a SQLite working copy compiled to WebAssembly. In the default shared mode the working copy is loaded from a hosted PostgreSQL database, and every change is sent back as one change set through a single database function that checks the revision and the state rules, so everyone sees the same café. The local demonstration mode keeps the data in the browser, as before.</a:t>
             </a:r>
           </a:p>
         </p:txBody>
@@ -1647,7 +1647,7 @@
           </a:p>
           <a:p>
             <a:r>
-              <a:t>The most delicate interaction is two candidates accepting at almost the same time. Each acceptance runs in one transaction that first re-reads the request state. Only the first finds it REQUESTED; the second sees ACCEPTED, rolls back, and the worker is told who already took the shift.</a:t>
+              <a:t>The most delicate interaction is two candidates accepting at almost the same time. Each acceptance runs in one transaction that first re-reads the request state. Only the first finds it REQUESTED; the second sees ACCEPTED, rolls back, and the worker is told who already took the shift. With the shared database the same holds across two phones: the database accepts only a change set based on the latest revision, so the slower phone reloads, re-runs the acceptance and gets the same message.</a:t>
             </a:r>
           </a:p>
         </p:txBody>
@@ -5030,8 +5030,8 @@
         </p:blipFill>
         <p:spPr>
           <a:xfrm>
-            <a:off x="640000" y="1912100"/>
-            <a:ext cx="10912000" cy="3125800"/>
+            <a:off x="640000" y="1767735"/>
+            <a:ext cx="10912000" cy="3414529"/>
           </a:xfrm>
           <a:prstGeom prst="rect">
             <a:avLst/>
@@ -5173,7 +5173,7 @@
                 </a:solidFill>
                 <a:latin typeface="Arial"/>
               </a:rPr>
-              <a:t>Vibe coding: seven prompt versions</a:t>
+              <a:t>Vibe coding: eight prompt versions</a:t>
             </a:r>
           </a:p>
         </p:txBody>
@@ -5227,7 +5227,7 @@
         </p:nvGraphicFramePr>
         <p:xfrm>
           <a:off x="640000" y="1450000"/>
-          <a:ext cx="10912000" cy="4900000"/>
+          <a:ext cx="10912000" cy="5600000"/>
         </p:xfrm>
         <a:graphic>
           <a:graphicData uri="http://schemas.openxmlformats.org/drawingml/2006/table">
@@ -5716,6 +5716,74 @@
                   </a:tcPr>
                 </a:tc>
               </a:tr>
+              <a:tr h="700000">
+                <a:tc>
+                  <a:txBody>
+                    <a:bodyPr/>
+                    <a:lstStyle/>
+                    <a:p>
+                      <a:r>
+                        <a:rPr sz="1400" b="1">
+                          <a:solidFill>
+                            <a:srgbClr val="1C2230"/>
+                          </a:solidFill>
+                          <a:latin typeface="Courier New"/>
+                        </a:rPr>
+                        <a:t>v8</a:t>
+                      </a:r>
+                    </a:p>
+                  </a:txBody>
+                  <a:tcPr>
+                    <a:solidFill>
+                      <a:srgbClr val="F4F6F9"/>
+                    </a:solidFill>
+                  </a:tcPr>
+                </a:tc>
+                <a:tc>
+                  <a:txBody>
+                    <a:bodyPr/>
+                    <a:lstStyle/>
+                    <a:p>
+                      <a:r>
+                        <a:rPr sz="1500" b="0">
+                          <a:solidFill>
+                            <a:srgbClr val="1C2230"/>
+                          </a:solidFill>
+                          <a:latin typeface="Arial"/>
+                        </a:rPr>
+                        <a:t>Proposal revision: shared data, part-time law</a:t>
+                      </a:r>
+                    </a:p>
+                  </a:txBody>
+                  <a:tcPr>
+                    <a:solidFill>
+                      <a:srgbClr val="FFFFFF"/>
+                    </a:solidFill>
+                  </a:tcPr>
+                </a:tc>
+                <a:tc>
+                  <a:txBody>
+                    <a:bodyPr/>
+                    <a:lstStyle/>
+                    <a:p>
+                      <a:r>
+                        <a:rPr sz="1500" b="0">
+                          <a:solidFill>
+                            <a:srgbClr val="1C2230"/>
+                          </a:solidFill>
+                          <a:latin typeface="Arial"/>
+                        </a:rPr>
+                        <a:t>Shared database with local fallback; part-time overtime and 12 h warning</a:t>
+                      </a:r>
+                    </a:p>
+                  </a:txBody>
+                  <a:tcPr>
+                    <a:solidFill>
+                      <a:srgbClr val="FFFFFF"/>
+                    </a:solidFill>
+                  </a:tcPr>
+                </a:tc>
+              </a:tr>
             </a:tbl>
           </a:graphicData>
         </a:graphic>
@@ -6503,7 +6571,7 @@
                 </a:solidFill>
                 <a:latin typeface="Arial"/>
               </a:rPr>
-              <a:t>89/89</a:t>
+              <a:t>125/125</a:t>
             </a:r>
           </a:p>
         </p:txBody>
@@ -6620,7 +6688,7 @@
                 </a:solidFill>
                 <a:latin typeface="Arial"/>
               </a:rPr>
-              <a:t>14/14</a:t>
+              <a:t>15/15</a:t>
             </a:r>
           </a:p>
         </p:txBody>
@@ -6737,7 +6805,7 @@
                 </a:solidFill>
                 <a:latin typeface="Arial"/>
               </a:rPr>
-              <a:t>89/89</a:t>
+              <a:t>113/113</a:t>
             </a:r>
           </a:p>
         </p:txBody>
@@ -6815,7 +6883,7 @@
                 </a:solidFill>
                 <a:latin typeface="Arial"/>
               </a:rPr>
-              <a:t>final prompt v7 re-run in an empty folder</a:t>
+              <a:t>final prompt v8 re-run in an empty folder</a:t>
             </a:r>
           </a:p>
         </p:txBody>
@@ -6854,7 +6922,7 @@
                 </a:solidFill>
                 <a:latin typeface="Arial"/>
               </a:rPr>
-              <a:t>21/21</a:t>
+              <a:t>23/23</a:t>
             </a:r>
           </a:p>
         </p:txBody>
@@ -7010,7 +7078,7 @@
                 </a:solidFill>
                 <a:latin typeface="Arial"/>
               </a:rPr>
-              <a:t>screen widths</a:t>
+              <a:t>browsers at once</a:t>
             </a:r>
           </a:p>
         </p:txBody>
@@ -7049,7 +7117,7 @@
                 </a:solidFill>
                 <a:latin typeface="Arial"/>
               </a:rPr>
-              <a:t>360 px and 1440 px, no horizontal scroll</a:t>
+              <a:t>shared database: one acceptance wins (12/12 checks)</a:t>
             </a:r>
           </a:p>
         </p:txBody>
@@ -7297,7 +7365,7 @@
                           </a:solidFill>
                           <a:latin typeface="Arial"/>
                         </a:rPr>
-                        <a:t>13 use cases · 11 tables · 5,648 lines of application code · 1,211 lines of tests</a:t>
+                        <a:t>13 use cases · 11 tables · 6,298 lines of application code · 1,788 lines of tests</a:t>
                       </a:r>
                     </a:p>
                   </a:txBody>
@@ -7343,7 +7411,7 @@
                           </a:solidFill>
                           <a:latin typeface="Arial"/>
                         </a:rPr>
-                        <a:t>Demo accounts without passwords · data stays in one browser · no messaging outside the app</a:t>
+                        <a:t>Demo accounts without passwords, so identity is not enforced · no messaging outside the app</a:t>
                       </a:r>
                     </a:p>
                   </a:txBody>
@@ -7389,7 +7457,7 @@
                           </a:solidFill>
                           <a:latin typeface="Arial"/>
                         </a:rPr>
-                        <a:t>Server-side database and login · KakaoTalk notifications · field test in the reference store</a:t>
+                        <a:t>Login with row-level ownership · KakaoTalk notifications · field test in the reference store</a:t>
                       </a:r>
                     </a:p>
                   </a:txBody>
@@ -8646,7 +8714,7 @@
                 </a:solidFill>
                 <a:latin typeface="Arial"/>
               </a:rPr>
-              <a:t>22</a:t>
+              <a:t>23</a:t>
             </a:r>
           </a:p>
         </p:txBody>
@@ -8724,7 +8792,7 @@
                 </a:solidFill>
                 <a:latin typeface="Arial"/>
               </a:rPr>
-              <a:t>FR-01 … FR-23, FR-03 retired</a:t>
+              <a:t>FR-01 … FR-24, FR-03 retired</a:t>
             </a:r>
           </a:p>
         </p:txBody>
@@ -8763,7 +8831,7 @@
                 </a:solidFill>
                 <a:latin typeface="Arial"/>
               </a:rPr>
-              <a:t>13</a:t>
+              <a:t>16</a:t>
             </a:r>
           </a:p>
         </p:txBody>
@@ -8880,7 +8948,7 @@
                 </a:solidFill>
                 <a:latin typeface="Arial"/>
               </a:rPr>
-              <a:t>14</a:t>
+              <a:t>15</a:t>
             </a:r>
           </a:p>
         </p:txBody>
@@ -8958,7 +9026,7 @@
                 </a:solidFill>
                 <a:latin typeface="Arial"/>
               </a:rPr>
-              <a:t>BR-01 … BR-14, each tested</a:t>
+              <a:t>BR-01 … BR-15, each tested</a:t>
             </a:r>
           </a:p>
         </p:txBody>
@@ -9075,7 +9143,7 @@
                 </a:solidFill>
                 <a:latin typeface="Arial"/>
               </a:rPr>
-              <a:t>SQLite schema</a:t>
+              <a:t>same schema in SQLite and PostgreSQL</a:t>
             </a:r>
           </a:p>
         </p:txBody>
@@ -9433,7 +9501,7 @@
         </p:nvGraphicFramePr>
         <p:xfrm>
           <a:off x="640000" y="1450000"/>
-          <a:ext cx="10912000" cy="2800000"/>
+          <a:ext cx="10912000" cy="3500000"/>
         </p:xfrm>
         <a:graphic>
           <a:graphicData uri="http://schemas.openxmlformats.org/drawingml/2006/table">
@@ -9663,6 +9731,74 @@
                           </a:solidFill>
                           <a:latin typeface="Courier New"/>
                         </a:rPr>
+                        <a:t>BR-08/15</a:t>
+                      </a:r>
+                    </a:p>
+                  </a:txBody>
+                  <a:tcPr>
+                    <a:solidFill>
+                      <a:srgbClr val="F4F6F9"/>
+                    </a:solidFill>
+                  </a:tcPr>
+                </a:tc>
+                <a:tc>
+                  <a:txBody>
+                    <a:bodyPr/>
+                    <a:lstStyle/>
+                    <a:p>
+                      <a:r>
+                        <a:rPr sz="1500" b="0">
+                          <a:solidFill>
+                            <a:srgbClr val="1C2230"/>
+                          </a:solidFill>
+                          <a:latin typeface="Arial"/>
+                        </a:rPr>
+                        <a:t>Part-time: hours beyond contract earn 50 %; warn above 12 h a week</a:t>
+                      </a:r>
+                    </a:p>
+                  </a:txBody>
+                  <a:tcPr>
+                    <a:solidFill>
+                      <a:srgbClr val="FFFFFF"/>
+                    </a:solidFill>
+                  </a:tcPr>
+                </a:tc>
+                <a:tc>
+                  <a:txBody>
+                    <a:bodyPr/>
+                    <a:lstStyle/>
+                    <a:p>
+                      <a:r>
+                        <a:rPr sz="1500" b="0">
+                          <a:solidFill>
+                            <a:srgbClr val="1C2230"/>
+                          </a:solidFill>
+                          <a:latin typeface="Arial"/>
+                        </a:rPr>
+                        <a:t>Fixed-term and Part-time Employees Act Art. 6</a:t>
+                      </a:r>
+                    </a:p>
+                  </a:txBody>
+                  <a:tcPr>
+                    <a:solidFill>
+                      <a:srgbClr val="FFFFFF"/>
+                    </a:solidFill>
+                  </a:tcPr>
+                </a:tc>
+              </a:tr>
+              <a:tr h="700000">
+                <a:tc>
+                  <a:txBody>
+                    <a:bodyPr/>
+                    <a:lstStyle/>
+                    <a:p>
+                      <a:r>
+                        <a:rPr sz="1400" b="1">
+                          <a:solidFill>
+                            <a:srgbClr val="1C2230"/>
+                          </a:solidFill>
+                          <a:latin typeface="Courier New"/>
+                        </a:rPr>
                         <a:t>BR-09/10</a:t>
                       </a:r>
                     </a:p>
@@ -10441,7 +10577,7 @@
                 </a:solidFill>
                 <a:latin typeface="Arial"/>
               </a:rPr>
-              <a:t>Architecture: a client-only web app</a:t>
+              <a:t>Architecture: a static web app and a shared database</a:t>
             </a:r>
           </a:p>
         </p:txBody>
@@ -10501,8 +10637,8 @@
         </p:blipFill>
         <p:spPr>
           <a:xfrm>
-            <a:off x="1037453" y="1250000"/>
-            <a:ext cx="10117094" cy="4450000"/>
+            <a:off x="1613590" y="1250000"/>
+            <a:ext cx="8964819" cy="4450000"/>
           </a:xfrm>
           <a:prstGeom prst="rect">
             <a:avLst/>
@@ -10543,7 +10679,7 @@
                 </a:solidFill>
                 <a:latin typeface="Arial"/>
               </a:rPr>
-              <a:t>Presentation → application services → pure rules → SQLite (sql.js, WebAssembly) → localStorage</a:t>
+              <a:t>Presentation → application services → pure rules → SQLite working copy (sql.js) → shared database (three RPC functions) or localStorage</a:t>
             </a:r>
           </a:p>
         </p:txBody>
@@ -10704,8 +10840,8 @@
         </p:blipFill>
         <p:spPr>
           <a:xfrm>
-            <a:off x="4584910" y="1250000"/>
-            <a:ext cx="3022179" cy="4450000"/>
+            <a:off x="4514140" y="1250000"/>
+            <a:ext cx="3163719" cy="4450000"/>
           </a:xfrm>
           <a:prstGeom prst="rect">
             <a:avLst/>

</xml_diff>